<commit_message>
fix: change Hermes Agent to projects-community platform deployment
</commit_message>
<xml_diff>
--- a/Guocai_Liang_中文简历_V2.pptx
+++ b/Guocai_Liang_中文简历_V2.pptx
@@ -3674,7 +3674,7 @@
               <a:defRPr sz="2800" b="1"/>
             </a:pPr>
             <a:r>
-              <a:t>Vibe Coding / AI 项目经历</a:t>
+              <a:t>Projects Community / Vibe Coding 项目经历</a:t>
             </a:r>
           </a:p>
         </p:txBody>
@@ -3705,7 +3705,7 @@
               <a:defRPr sz="1400" b="1"/>
             </a:pPr>
             <a:r>
-              <a:t>1. Hermes AI Agent 系统部署与多平台消息网关</a:t>
+              <a:t>1. Projects Community — 全栈 AI 工作流与社区平台</a:t>
             </a:r>
           </a:p>
         </p:txBody>
@@ -3719,7 +3719,7 @@
         <p:spPr>
           <a:xfrm>
             <a:off x="640080" y="1463040"/>
-            <a:ext cx="7863840" cy="914400"/>
+            <a:ext cx="7863840" cy="1005840"/>
           </a:xfrm>
           <a:prstGeom prst="rect">
             <a:avLst/>
@@ -3744,7 +3744,7 @@
           </a:p>
           <a:p>
             <a:r>
-              <a:t>• 自研部署 Hermes Agent AI 框架，整合 Codex、Claude Code、Opencode.ai 多模型路由</a:t>
+              <a:t>• 基于 Hermes Agent 框架部署个人 AI 助手系统，整合 Codex、Claude Code、Opencode.ai 多模型路由</a:t>
             </a:r>
           </a:p>
           <a:p>
@@ -3754,12 +3754,12 @@
           </a:p>
           <a:p>
             <a:r>
-              <a:t>• Antigravity + Codex 并行代码生成，故障排查效率提升 60%</a:t>
+              <a:t>• Antigravity + Codex 并行代码生成与 PR Review 自动化，故障排查效率提升 60%</a:t>
             </a:r>
           </a:p>
           <a:p>
             <a:r>
-              <a:t>• Python 3.11、FastAPI、systemd、Docker Compose、MCP Adapter</a:t>
+              <a:t>• 技术栈：Python 3.11、FastAPI、SQLite、systemd、Docker Compose</a:t>
             </a:r>
           </a:p>
         </p:txBody>
@@ -3772,7 +3772,7 @@
         </p:nvSpPr>
         <p:spPr>
           <a:xfrm>
-            <a:off x="457200" y="2468880"/>
+            <a:off x="457200" y="2560320"/>
             <a:ext cx="8229600" cy="457200"/>
           </a:xfrm>
           <a:prstGeom prst="rect">
@@ -3790,7 +3790,7 @@
               <a:defRPr sz="1400" b="1"/>
             </a:pPr>
             <a:r>
-              <a:t>2. Hermes MCP Adapter — 本地 AI 运行时对外适配器</a:t>
+              <a:t>2. Hermes MCP Adapter — 本地 AI 运行时外部调用适配器</a:t>
             </a:r>
           </a:p>
         </p:txBody>
@@ -3803,8 +3803,8 @@
         </p:nvSpPr>
         <p:spPr>
           <a:xfrm>
-            <a:off x="640080" y="2834640"/>
-            <a:ext cx="7863840" cy="914400"/>
+            <a:off x="640080" y="2926079"/>
+            <a:ext cx="7863840" cy="1005840"/>
           </a:xfrm>
           <a:prstGeom prst="rect">
             <a:avLst/>
@@ -3829,17 +3829,17 @@
           </a:p>
           <a:p>
             <a:r>
-              <a:t>• 开发 Hermes MCP Adapter，暴露本地运行时为 MCP 标准服务端点</a:t>
+              <a:t>• 独立开发适配器，将本地 Hermes 运行时暴露为符合 MCP（Model Context Protocol）标准的服务端点</a:t>
             </a:r>
           </a:p>
           <a:p>
             <a:r>
-              <a:t>• 支持 Cursor/Claude Desktop 直接调用，命令白名单 + HTTP 转发</a:t>
+              <a:t>• 支持 Cursor、Claude Desktop 等客户端直接调用本地命令，实现白名单校验、HTTP 转发、健康检查</a:t>
             </a:r>
           </a:p>
           <a:p>
             <a:r>
-              <a:t>• TypeScript、Node.js、FastAPI、MCP stdio/HTTP</a:t>
+              <a:t>• 技术栈：TypeScript、Node.js、FastAPI、MCP stdio/HTTP</a:t>
             </a:r>
           </a:p>
         </p:txBody>
@@ -3852,7 +3852,7 @@
         </p:nvSpPr>
         <p:spPr>
           <a:xfrm>
-            <a:off x="457200" y="3840480"/>
+            <a:off x="457200" y="4023360"/>
             <a:ext cx="8229600" cy="457200"/>
           </a:xfrm>
           <a:prstGeom prst="rect">
@@ -3883,8 +3883,8 @@
         </p:nvSpPr>
         <p:spPr>
           <a:xfrm>
-            <a:off x="640080" y="4206240"/>
-            <a:ext cx="7863840" cy="914400"/>
+            <a:off x="640080" y="4389120"/>
+            <a:ext cx="7863840" cy="1005840"/>
           </a:xfrm>
           <a:prstGeom prst="rect">
             <a:avLst/>
@@ -3909,17 +3909,22 @@
           </a:p>
           <a:p>
             <a:r>
-              <a:t>• 主导设计“POV 梦幻油画铁轨梦境”运镜脚本：花海云端 → 海底世界</a:t>
+              <a:t>• 主导设计“POV 梦幻油画铁轨梦境”运镜脚本：花海云端 → 海底世界 7 个场景转场</a:t>
             </a:r>
           </a:p>
           <a:p>
             <a:r>
-              <a:t>• Kling AI 3.0、Runway Gen-3、Pika 2.0 流水线化生成，单片 8-10 秒</a:t>
+              <a:t>• 利用 Kling AI 3.0、Runway Gen-3、Pika 2.0 工具实现流水线化生成，单片 8-10 秒</a:t>
             </a:r>
           </a:p>
           <a:p>
             <a:r>
-              <a:t>• 建立 prompt engineering 知识库（GitHub），形成可复用模板</a:t>
+              <a:t>• 建立 prompt engineering 知识库（GitHub repo），系统归纳运镜、锁定句、分段拼接策略</a:t>
+            </a:r>
+          </a:p>
+          <a:p>
+            <a:r>
+              <a:t>• 技术栈：AI Video Gen、Prompt Engineering、Markdown</a:t>
             </a:r>
           </a:p>
         </p:txBody>
@@ -3932,7 +3937,7 @@
         </p:nvSpPr>
         <p:spPr>
           <a:xfrm>
-            <a:off x="457200" y="5212080"/>
+            <a:off x="457200" y="5486400"/>
             <a:ext cx="8229600" cy="457200"/>
           </a:xfrm>
           <a:prstGeom prst="rect">
@@ -3950,7 +3955,7 @@
               <a:defRPr sz="1400" b="1"/>
             </a:pPr>
             <a:r>
-              <a:t>4. 混合云 VPS 基础设施</a:t>
+              <a:t>4. 混合云 VPS 基础设施与边缘计算</a:t>
             </a:r>
           </a:p>
         </p:txBody>
@@ -3963,8 +3968,8 @@
         </p:nvSpPr>
         <p:spPr>
           <a:xfrm>
-            <a:off x="640080" y="5577840"/>
-            <a:ext cx="7863840" cy="914400"/>
+            <a:off x="640080" y="5852160"/>
+            <a:ext cx="7863840" cy="1005840"/>
           </a:xfrm>
           <a:prstGeom prst="rect">
             <a:avLst/>
@@ -3989,17 +3994,22 @@
           </a:p>
           <a:p>
             <a:r>
-              <a:t>• 统管腾讯云 + Vultr 三台 VPS，Coolify PaaS + 3x-ui 代理 + Cloudflare Tunnel</a:t>
+              <a:t>• 统管腾讯云、Vultr 三台 VPS，构建 Coolify PaaS 私服 + 3x-ui 代理网关 + Cloudflare Tunnel 动态路由</a:t>
             </a:r>
           </a:p>
           <a:p>
             <a:r>
-              <a:t>• 原生 systemd 部署，内存占用降低 40%</a:t>
+              <a:t>• 自研 Cloudflare Tunnel 自动化配置脚本，解决 ICP 防火墙阻断问题</a:t>
             </a:r>
           </a:p>
           <a:p>
             <a:r>
-              <a:t>• Ubuntu、Docker、systemd、Traefik、PostgreSQL、Redis</a:t>
+              <a:t>• 原生 systemd 部署优先策略：Hermes、PostgreSQL、Redis 原生运行，内存占用降低 40%</a:t>
+            </a:r>
+          </a:p>
+          <a:p>
+            <a:r>
+              <a:t>• 技术栈：Ubuntu 22.04、Docker、systemd、Traefik、Nginx、PostgreSQL、Redis</a:t>
             </a:r>
           </a:p>
         </p:txBody>

</xml_diff>

<commit_message>
Fix and update primary Chinese resume
</commit_message>
<xml_diff>
--- a/Guocai_Liang_中文简历_V2.pptx
+++ b/Guocai_Liang_中文简历_V2.pptx
@@ -9,7 +9,6 @@
   </p:notesMasterIdLst>
   <p:sldIdLst>
     <p:sldId xmlns:r="http://schemas.openxmlformats.org/officeDocument/2006/relationships" id="256" r:id="R55e2241f55d342b4"/>
-    <p:sldId xmlns:ns0="http://schemas.openxmlformats.org/officeDocument/2006/relationships" id="257" ns0:id="rId7"/>
   </p:sldIdLst>
   <p:sldSz cx="7772400" cy="10058400"/>
   <p:notesSz cx="6858000" cy="9144000"/>
@@ -1202,12 +1201,12 @@
           </a:ln>
         </p:spPr>
         <p:txBody>
-          <a:bodyPr xmlns:a="http://schemas.openxmlformats.org/drawingml/2006/main" wrap="square" lIns="0" tIns="0" rIns="0" bIns="0" anchor="t"/>
+          <a:bodyPr xmlns:a="http://schemas.openxmlformats.org/drawingml/2006/main" wrap="square" lIns="18300" tIns="18300" rIns="18300" bIns="18300" anchor="t"/>
           <a:lstStyle xmlns:a="http://schemas.openxmlformats.org/drawingml/2006/main"/>
           <a:p xmlns:a="http://schemas.openxmlformats.org/drawingml/2006/main">
             <a:pPr algn="l">
               <a:lnSpc>
-                <a:spcPct val="108000"/>
+                <a:spcPct val="80000"/>
               </a:lnSpc>
               <a:buNone/>
               <a:defRPr sz="1650" b="1">
@@ -1249,7 +1248,7 @@
         </p:nvSpPr>
         <p:spPr>
           <a:xfrm xmlns:a="http://schemas.openxmlformats.org/drawingml/2006/main">
-            <a:off x="285750" y="590550"/>
+            <a:off x="285750" y="571500"/>
             <a:ext cx="1714500" cy="190500"/>
           </a:xfrm>
           <a:prstGeom xmlns:a="http://schemas.openxmlformats.org/drawingml/2006/main" prst="rect">
@@ -1262,12 +1261,12 @@
           </a:ln>
         </p:spPr>
         <p:txBody>
-          <a:bodyPr xmlns:a="http://schemas.openxmlformats.org/drawingml/2006/main" wrap="square" lIns="0" tIns="0" rIns="0" bIns="0" anchor="t"/>
+          <a:bodyPr xmlns:a="http://schemas.openxmlformats.org/drawingml/2006/main" wrap="square" lIns="18300" tIns="18300" rIns="18300" bIns="18300" anchor="t"/>
           <a:lstStyle xmlns:a="http://schemas.openxmlformats.org/drawingml/2006/main"/>
           <a:p xmlns:a="http://schemas.openxmlformats.org/drawingml/2006/main">
             <a:pPr algn="l">
               <a:lnSpc>
-                <a:spcPct val="108000"/>
+                <a:spcPct val="80000"/>
               </a:lnSpc>
               <a:buNone/>
               <a:defRPr sz="1050" b="0">
@@ -1309,7 +1308,7 @@
         </p:nvSpPr>
         <p:spPr>
           <a:xfrm xmlns:a="http://schemas.openxmlformats.org/drawingml/2006/main">
-            <a:off x="876300" y="838200"/>
+            <a:off x="876300" y="762000"/>
             <a:ext cx="5048250" cy="190500"/>
           </a:xfrm>
           <a:prstGeom xmlns:a="http://schemas.openxmlformats.org/drawingml/2006/main" prst="rect">
@@ -1322,12 +1321,12 @@
           </a:ln>
         </p:spPr>
         <p:txBody>
-          <a:bodyPr xmlns:a="http://schemas.openxmlformats.org/drawingml/2006/main" wrap="square" lIns="0" tIns="0" rIns="0" bIns="0" anchor="t"/>
+          <a:bodyPr xmlns:a="http://schemas.openxmlformats.org/drawingml/2006/main" wrap="square" lIns="18300" tIns="18300" rIns="18300" bIns="18300" anchor="t"/>
           <a:lstStyle xmlns:a="http://schemas.openxmlformats.org/drawingml/2006/main"/>
           <a:p xmlns:a="http://schemas.openxmlformats.org/drawingml/2006/main">
             <a:pPr algn="ctr">
               <a:lnSpc>
-                <a:spcPct val="108000"/>
+                <a:spcPct val="80000"/>
               </a:lnSpc>
               <a:buNone/>
               <a:defRPr sz="953" b="0">
@@ -1369,7 +1368,7 @@
         </p:nvSpPr>
         <p:spPr>
           <a:xfrm xmlns:a="http://schemas.openxmlformats.org/drawingml/2006/main">
-            <a:off x="2571750" y="1076325"/>
+            <a:off x="2571750" y="952500"/>
             <a:ext cx="2571750" cy="171450"/>
           </a:xfrm>
           <a:prstGeom xmlns:a="http://schemas.openxmlformats.org/drawingml/2006/main" prst="rect">
@@ -1382,12 +1381,12 @@
           </a:ln>
         </p:spPr>
         <p:txBody>
-          <a:bodyPr xmlns:a="http://schemas.openxmlformats.org/drawingml/2006/main" wrap="square" lIns="0" tIns="0" rIns="0" bIns="0" anchor="t"/>
+          <a:bodyPr xmlns:a="http://schemas.openxmlformats.org/drawingml/2006/main" wrap="square" lIns="18300" tIns="18300" rIns="18300" bIns="18300" anchor="t"/>
           <a:lstStyle xmlns:a="http://schemas.openxmlformats.org/drawingml/2006/main"/>
           <a:p xmlns:a="http://schemas.openxmlformats.org/drawingml/2006/main">
             <a:pPr algn="ctr">
               <a:lnSpc>
-                <a:spcPct val="108000"/>
+                <a:spcPct val="80000"/>
               </a:lnSpc>
               <a:buNone/>
               <a:defRPr sz="953" b="0">
@@ -1429,7 +1428,7 @@
         </p:nvSpPr>
         <p:spPr>
           <a:xfrm xmlns:a="http://schemas.openxmlformats.org/drawingml/2006/main">
-            <a:off x="266700" y="1428750"/>
+            <a:off x="266700" y="1123950"/>
             <a:ext cx="2667000" cy="190500"/>
           </a:xfrm>
           <a:prstGeom xmlns:a="http://schemas.openxmlformats.org/drawingml/2006/main" prst="rect">
@@ -1442,12 +1441,12 @@
           </a:ln>
         </p:spPr>
         <p:txBody>
-          <a:bodyPr xmlns:a="http://schemas.openxmlformats.org/drawingml/2006/main" wrap="square" lIns="0" tIns="0" rIns="0" bIns="0" anchor="t"/>
+          <a:bodyPr xmlns:a="http://schemas.openxmlformats.org/drawingml/2006/main" wrap="square" lIns="18300" tIns="18300" rIns="18300" bIns="18300" anchor="t"/>
           <a:lstStyle xmlns:a="http://schemas.openxmlformats.org/drawingml/2006/main"/>
           <a:p xmlns:a="http://schemas.openxmlformats.org/drawingml/2006/main">
             <a:pPr algn="l">
               <a:lnSpc>
-                <a:spcPct val="108000"/>
+                <a:spcPct val="80000"/>
               </a:lnSpc>
               <a:buNone/>
               <a:defRPr sz="1200" b="1">
@@ -1489,7 +1488,7 @@
         </p:nvSpPr>
         <p:spPr>
           <a:xfrm xmlns:a="http://schemas.openxmlformats.org/drawingml/2006/main">
-            <a:off x="266700" y="1647825"/>
+            <a:off x="266700" y="1319450"/>
             <a:ext cx="7239000" cy="20955"/>
           </a:xfrm>
           <a:prstGeom xmlns:a="http://schemas.openxmlformats.org/drawingml/2006/main" prst="rect">
@@ -1522,7 +1521,7 @@
         </p:nvSpPr>
         <p:spPr>
           <a:xfrm xmlns:a="http://schemas.openxmlformats.org/drawingml/2006/main">
-            <a:off x="266700" y="1724025"/>
+            <a:off x="266700" y="1335405"/>
             <a:ext cx="4953000" cy="190500"/>
           </a:xfrm>
           <a:prstGeom xmlns:a="http://schemas.openxmlformats.org/drawingml/2006/main" prst="rect">
@@ -1535,12 +1534,12 @@
           </a:ln>
         </p:spPr>
         <p:txBody>
-          <a:bodyPr xmlns:a="http://schemas.openxmlformats.org/drawingml/2006/main" wrap="square" lIns="0" tIns="0" rIns="0" bIns="0" anchor="t"/>
+          <a:bodyPr xmlns:a="http://schemas.openxmlformats.org/drawingml/2006/main" wrap="square" lIns="18300" tIns="18300" rIns="18300" bIns="18300" anchor="t"/>
           <a:lstStyle xmlns:a="http://schemas.openxmlformats.org/drawingml/2006/main"/>
           <a:p xmlns:a="http://schemas.openxmlformats.org/drawingml/2006/main">
             <a:pPr algn="l">
               <a:lnSpc>
-                <a:spcPct val="108000"/>
+                <a:spcPct val="80000"/>
               </a:lnSpc>
               <a:buNone/>
               <a:defRPr sz="1058" b="1">
@@ -1582,7 +1581,7 @@
         </p:nvSpPr>
         <p:spPr>
           <a:xfrm xmlns:a="http://schemas.openxmlformats.org/drawingml/2006/main">
-            <a:off x="5810250" y="1724025"/>
+            <a:off x="5810250" y="1335405"/>
             <a:ext cx="1428750" cy="190500"/>
           </a:xfrm>
           <a:prstGeom xmlns:a="http://schemas.openxmlformats.org/drawingml/2006/main" prst="rect">
@@ -1595,12 +1594,12 @@
           </a:ln>
         </p:spPr>
         <p:txBody>
-          <a:bodyPr xmlns:a="http://schemas.openxmlformats.org/drawingml/2006/main" wrap="square" lIns="0" tIns="0" rIns="0" bIns="0" anchor="t"/>
+          <a:bodyPr xmlns:a="http://schemas.openxmlformats.org/drawingml/2006/main" wrap="square" lIns="18300" tIns="18300" rIns="18300" bIns="18300" anchor="t"/>
           <a:lstStyle xmlns:a="http://schemas.openxmlformats.org/drawingml/2006/main"/>
           <a:p xmlns:a="http://schemas.openxmlformats.org/drawingml/2006/main">
             <a:pPr algn="r">
               <a:lnSpc>
-                <a:spcPct val="108000"/>
+                <a:spcPct val="80000"/>
               </a:lnSpc>
               <a:buNone/>
               <a:defRPr sz="1058" b="1">
@@ -1642,7 +1641,7 @@
         </p:nvSpPr>
         <p:spPr>
           <a:xfrm xmlns:a="http://schemas.openxmlformats.org/drawingml/2006/main">
-            <a:off x="266700" y="1943100"/>
+            <a:off x="266700" y="1525905"/>
             <a:ext cx="3429000" cy="171450"/>
           </a:xfrm>
           <a:prstGeom xmlns:a="http://schemas.openxmlformats.org/drawingml/2006/main" prst="rect">
@@ -1655,12 +1654,12 @@
           </a:ln>
         </p:spPr>
         <p:txBody>
-          <a:bodyPr xmlns:a="http://schemas.openxmlformats.org/drawingml/2006/main" wrap="square" lIns="0" tIns="0" rIns="0" bIns="0" anchor="t"/>
+          <a:bodyPr xmlns:a="http://schemas.openxmlformats.org/drawingml/2006/main" wrap="square" lIns="18300" tIns="18300" rIns="18300" bIns="18300" anchor="t"/>
           <a:lstStyle xmlns:a="http://schemas.openxmlformats.org/drawingml/2006/main"/>
           <a:p xmlns:a="http://schemas.openxmlformats.org/drawingml/2006/main">
             <a:pPr algn="l">
               <a:lnSpc>
-                <a:spcPct val="108000"/>
+                <a:spcPct val="80000"/>
               </a:lnSpc>
               <a:buNone/>
               <a:defRPr sz="1005" b="1">
@@ -1702,7 +1701,7 @@
         </p:nvSpPr>
         <p:spPr>
           <a:xfrm xmlns:a="http://schemas.openxmlformats.org/drawingml/2006/main">
-            <a:off x="266700" y="2181225"/>
+            <a:off x="266700" y="1697355"/>
             <a:ext cx="6858000" cy="247650"/>
           </a:xfrm>
           <a:prstGeom xmlns:a="http://schemas.openxmlformats.org/drawingml/2006/main" prst="rect">
@@ -1715,16 +1714,13 @@
           </a:ln>
         </p:spPr>
         <p:txBody>
-          <a:bodyPr xmlns:a="http://schemas.openxmlformats.org/drawingml/2006/main" wrap="square" lIns="0" tIns="0" rIns="0" bIns="0" anchor="t"/>
+          <a:bodyPr xmlns:a="http://schemas.openxmlformats.org/drawingml/2006/main" wrap="square" lIns="18300" tIns="18300" rIns="18300" bIns="18300" anchor="t"/>
           <a:lstStyle xmlns:a="http://schemas.openxmlformats.org/drawingml/2006/main"/>
           <a:p xmlns:a="http://schemas.openxmlformats.org/drawingml/2006/main">
             <a:pPr marL="12" indent="-10" algn="l">
               <a:lnSpc>
-                <a:spcPct val="108000"/>
+                <a:spcPct val="80000"/>
               </a:lnSpc>
-              <a:spcAft>
-                <a:spcPts val="3"/>
-              </a:spcAft>
               <a:buNone/>
               <a:defRPr sz="953" b="0">
                 <a:solidFill>
@@ -1787,7 +1783,7 @@
         </p:nvSpPr>
         <p:spPr>
           <a:xfrm xmlns:a="http://schemas.openxmlformats.org/drawingml/2006/main">
-            <a:off x="266700" y="2505075"/>
+            <a:off x="266700" y="1945005"/>
             <a:ext cx="2667000" cy="190500"/>
           </a:xfrm>
           <a:prstGeom xmlns:a="http://schemas.openxmlformats.org/drawingml/2006/main" prst="rect">
@@ -1800,12 +1796,12 @@
           </a:ln>
         </p:spPr>
         <p:txBody>
-          <a:bodyPr xmlns:a="http://schemas.openxmlformats.org/drawingml/2006/main" wrap="square" lIns="0" tIns="0" rIns="0" bIns="0" anchor="t"/>
+          <a:bodyPr xmlns:a="http://schemas.openxmlformats.org/drawingml/2006/main" wrap="square" lIns="18300" tIns="18300" rIns="18300" bIns="18300" anchor="t"/>
           <a:lstStyle xmlns:a="http://schemas.openxmlformats.org/drawingml/2006/main"/>
           <a:p xmlns:a="http://schemas.openxmlformats.org/drawingml/2006/main">
             <a:pPr algn="l">
               <a:lnSpc>
-                <a:spcPct val="108000"/>
+                <a:spcPct val="80000"/>
               </a:lnSpc>
               <a:buNone/>
               <a:defRPr sz="1200" b="1">
@@ -1847,7 +1843,7 @@
         </p:nvSpPr>
         <p:spPr>
           <a:xfrm xmlns:a="http://schemas.openxmlformats.org/drawingml/2006/main">
-            <a:off x="266700" y="2724150"/>
+            <a:off x="266700" y="2140505"/>
             <a:ext cx="7239000" cy="20955"/>
           </a:xfrm>
           <a:prstGeom xmlns:a="http://schemas.openxmlformats.org/drawingml/2006/main" prst="rect">
@@ -1880,7 +1876,7 @@
         </p:nvSpPr>
         <p:spPr>
           <a:xfrm xmlns:a="http://schemas.openxmlformats.org/drawingml/2006/main">
-            <a:off x="266700" y="2800350"/>
+            <a:off x="266700" y="2867025"/>
             <a:ext cx="4953000" cy="190500"/>
           </a:xfrm>
           <a:prstGeom xmlns:a="http://schemas.openxmlformats.org/drawingml/2006/main" prst="rect">
@@ -1893,12 +1889,12 @@
           </a:ln>
         </p:spPr>
         <p:txBody>
-          <a:bodyPr xmlns:a="http://schemas.openxmlformats.org/drawingml/2006/main" wrap="square" lIns="0" tIns="0" rIns="0" bIns="0" anchor="t"/>
+          <a:bodyPr xmlns:a="http://schemas.openxmlformats.org/drawingml/2006/main" wrap="square" lIns="18300" tIns="18300" rIns="18300" bIns="18300" anchor="t"/>
           <a:lstStyle xmlns:a="http://schemas.openxmlformats.org/drawingml/2006/main"/>
           <a:p xmlns:a="http://schemas.openxmlformats.org/drawingml/2006/main">
             <a:pPr algn="l">
               <a:lnSpc>
-                <a:spcPct val="108000"/>
+                <a:spcPct val="80000"/>
               </a:lnSpc>
               <a:buNone/>
               <a:defRPr sz="1058" b="1">
@@ -1940,7 +1936,7 @@
         </p:nvSpPr>
         <p:spPr>
           <a:xfrm xmlns:a="http://schemas.openxmlformats.org/drawingml/2006/main">
-            <a:off x="5810250" y="2800350"/>
+            <a:off x="5810250" y="2867025"/>
             <a:ext cx="1428750" cy="190500"/>
           </a:xfrm>
           <a:prstGeom xmlns:a="http://schemas.openxmlformats.org/drawingml/2006/main" prst="rect">
@@ -1953,12 +1949,12 @@
           </a:ln>
         </p:spPr>
         <p:txBody>
-          <a:bodyPr xmlns:a="http://schemas.openxmlformats.org/drawingml/2006/main" wrap="square" lIns="0" tIns="0" rIns="0" bIns="0" anchor="t"/>
+          <a:bodyPr xmlns:a="http://schemas.openxmlformats.org/drawingml/2006/main" wrap="square" lIns="18300" tIns="18300" rIns="18300" bIns="18300" anchor="t"/>
           <a:lstStyle xmlns:a="http://schemas.openxmlformats.org/drawingml/2006/main"/>
           <a:p xmlns:a="http://schemas.openxmlformats.org/drawingml/2006/main">
             <a:pPr algn="r">
               <a:lnSpc>
-                <a:spcPct val="108000"/>
+                <a:spcPct val="80000"/>
               </a:lnSpc>
               <a:buNone/>
               <a:defRPr sz="1058" b="1">
@@ -2000,8 +1996,8 @@
         </p:nvSpPr>
         <p:spPr>
           <a:xfrm xmlns:a="http://schemas.openxmlformats.org/drawingml/2006/main">
-            <a:off x="266700" y="3038475"/>
-            <a:ext cx="7000875" cy="666750"/>
+            <a:off x="266700" y="3057525"/>
+            <a:ext cx="7000875" cy="520065"/>
           </a:xfrm>
           <a:prstGeom xmlns:a="http://schemas.openxmlformats.org/drawingml/2006/main" prst="rect">
             <a:avLst/>
@@ -2013,16 +2009,13 @@
           </a:ln>
         </p:spPr>
         <p:txBody>
-          <a:bodyPr xmlns:a="http://schemas.openxmlformats.org/drawingml/2006/main" wrap="square" lIns="0" tIns="0" rIns="0" bIns="0" anchor="t"/>
+          <a:bodyPr xmlns:a="http://schemas.openxmlformats.org/drawingml/2006/main" wrap="square" lIns="18300" tIns="18300" rIns="18300" bIns="18300" anchor="t"/>
           <a:lstStyle xmlns:a="http://schemas.openxmlformats.org/drawingml/2006/main"/>
           <a:p xmlns:a="http://schemas.openxmlformats.org/drawingml/2006/main">
             <a:pPr marL="12" indent="-10" algn="l">
               <a:lnSpc>
-                <a:spcPct val="108000"/>
+                <a:spcPct val="80000"/>
               </a:lnSpc>
-              <a:spcAft>
-                <a:spcPts val="3"/>
-              </a:spcAft>
               <a:buNone/>
               <a:defRPr sz="953" b="0">
                 <a:solidFill>
@@ -2070,11 +2063,8 @@
           <a:p xmlns:a="http://schemas.openxmlformats.org/drawingml/2006/main">
             <a:pPr marL="12" indent="-10" algn="l">
               <a:lnSpc>
-                <a:spcPct val="108000"/>
+                <a:spcPct val="80000"/>
               </a:lnSpc>
-              <a:spcAft>
-                <a:spcPts val="3"/>
-              </a:spcAft>
               <a:buNone/>
               <a:defRPr sz="953" b="0">
                 <a:solidFill>
@@ -2122,11 +2112,8 @@
           <a:p xmlns:a="http://schemas.openxmlformats.org/drawingml/2006/main">
             <a:pPr marL="12" indent="-10" algn="l">
               <a:lnSpc>
-                <a:spcPct val="108000"/>
+                <a:spcPct val="80000"/>
               </a:lnSpc>
-              <a:spcAft>
-                <a:spcPts val="3"/>
-              </a:spcAft>
               <a:buNone/>
               <a:defRPr sz="953" b="0">
                 <a:solidFill>
@@ -2189,7 +2176,7 @@
         </p:nvSpPr>
         <p:spPr>
           <a:xfrm xmlns:a="http://schemas.openxmlformats.org/drawingml/2006/main">
-            <a:off x="266700" y="3752850"/>
+            <a:off x="266700" y="3577590"/>
             <a:ext cx="4953000" cy="190500"/>
           </a:xfrm>
           <a:prstGeom xmlns:a="http://schemas.openxmlformats.org/drawingml/2006/main" prst="rect">
@@ -2202,12 +2189,12 @@
           </a:ln>
         </p:spPr>
         <p:txBody>
-          <a:bodyPr xmlns:a="http://schemas.openxmlformats.org/drawingml/2006/main" wrap="square" lIns="0" tIns="0" rIns="0" bIns="0" anchor="t"/>
+          <a:bodyPr xmlns:a="http://schemas.openxmlformats.org/drawingml/2006/main" wrap="square" lIns="18300" tIns="18300" rIns="18300" bIns="18300" anchor="t"/>
           <a:lstStyle xmlns:a="http://schemas.openxmlformats.org/drawingml/2006/main"/>
           <a:p xmlns:a="http://schemas.openxmlformats.org/drawingml/2006/main">
             <a:pPr algn="l">
               <a:lnSpc>
-                <a:spcPct val="108000"/>
+                <a:spcPct val="80000"/>
               </a:lnSpc>
               <a:buNone/>
               <a:defRPr sz="1058" b="1">
@@ -2249,7 +2236,7 @@
         </p:nvSpPr>
         <p:spPr>
           <a:xfrm xmlns:a="http://schemas.openxmlformats.org/drawingml/2006/main">
-            <a:off x="5810250" y="3752850"/>
+            <a:off x="5810250" y="3577590"/>
             <a:ext cx="1428750" cy="190500"/>
           </a:xfrm>
           <a:prstGeom xmlns:a="http://schemas.openxmlformats.org/drawingml/2006/main" prst="rect">
@@ -2262,12 +2249,12 @@
           </a:ln>
         </p:spPr>
         <p:txBody>
-          <a:bodyPr xmlns:a="http://schemas.openxmlformats.org/drawingml/2006/main" wrap="square" lIns="0" tIns="0" rIns="0" bIns="0" anchor="t"/>
+          <a:bodyPr xmlns:a="http://schemas.openxmlformats.org/drawingml/2006/main" wrap="square" lIns="18300" tIns="18300" rIns="18300" bIns="18300" anchor="t"/>
           <a:lstStyle xmlns:a="http://schemas.openxmlformats.org/drawingml/2006/main"/>
           <a:p xmlns:a="http://schemas.openxmlformats.org/drawingml/2006/main">
             <a:pPr algn="r">
               <a:lnSpc>
-                <a:spcPct val="108000"/>
+                <a:spcPct val="80000"/>
               </a:lnSpc>
               <a:buNone/>
               <a:defRPr sz="1058" b="1">
@@ -2309,8 +2296,8 @@
         </p:nvSpPr>
         <p:spPr>
           <a:xfrm xmlns:a="http://schemas.openxmlformats.org/drawingml/2006/main">
-            <a:off x="266700" y="3990975"/>
-            <a:ext cx="7000875" cy="666750"/>
+            <a:off x="266700" y="3768090"/>
+            <a:ext cx="7000875" cy="520065"/>
           </a:xfrm>
           <a:prstGeom xmlns:a="http://schemas.openxmlformats.org/drawingml/2006/main" prst="rect">
             <a:avLst/>
@@ -2322,16 +2309,13 @@
           </a:ln>
         </p:spPr>
         <p:txBody>
-          <a:bodyPr xmlns:a="http://schemas.openxmlformats.org/drawingml/2006/main" wrap="square" lIns="0" tIns="0" rIns="0" bIns="0" anchor="t"/>
+          <a:bodyPr xmlns:a="http://schemas.openxmlformats.org/drawingml/2006/main" wrap="square" lIns="18300" tIns="18300" rIns="18300" bIns="18300" anchor="t"/>
           <a:lstStyle xmlns:a="http://schemas.openxmlformats.org/drawingml/2006/main"/>
           <a:p xmlns:a="http://schemas.openxmlformats.org/drawingml/2006/main">
             <a:pPr marL="12" indent="-10" algn="l">
               <a:lnSpc>
-                <a:spcPct val="108000"/>
+                <a:spcPct val="80000"/>
               </a:lnSpc>
-              <a:spcAft>
-                <a:spcPts val="3"/>
-              </a:spcAft>
               <a:buNone/>
               <a:defRPr sz="953" b="0">
                 <a:solidFill>
@@ -2379,11 +2363,8 @@
           <a:p xmlns:a="http://schemas.openxmlformats.org/drawingml/2006/main">
             <a:pPr marL="12" indent="-10" algn="l">
               <a:lnSpc>
-                <a:spcPct val="108000"/>
+                <a:spcPct val="80000"/>
               </a:lnSpc>
-              <a:spcAft>
-                <a:spcPts val="3"/>
-              </a:spcAft>
               <a:buNone/>
               <a:defRPr sz="953" b="0">
                 <a:solidFill>
@@ -2431,11 +2412,8 @@
           <a:p xmlns:a="http://schemas.openxmlformats.org/drawingml/2006/main">
             <a:pPr marL="12" indent="-10" algn="l">
               <a:lnSpc>
-                <a:spcPct val="108000"/>
+                <a:spcPct val="80000"/>
               </a:lnSpc>
-              <a:spcAft>
-                <a:spcPts val="3"/>
-              </a:spcAft>
               <a:buNone/>
               <a:defRPr sz="953" b="0">
                 <a:solidFill>
@@ -2498,7 +2476,7 @@
         </p:nvSpPr>
         <p:spPr>
           <a:xfrm xmlns:a="http://schemas.openxmlformats.org/drawingml/2006/main">
-            <a:off x="266700" y="4705350"/>
+            <a:off x="266700" y="4288155"/>
             <a:ext cx="4953000" cy="190500"/>
           </a:xfrm>
           <a:prstGeom xmlns:a="http://schemas.openxmlformats.org/drawingml/2006/main" prst="rect">
@@ -2511,12 +2489,12 @@
           </a:ln>
         </p:spPr>
         <p:txBody>
-          <a:bodyPr xmlns:a="http://schemas.openxmlformats.org/drawingml/2006/main" wrap="square" lIns="0" tIns="0" rIns="0" bIns="0" anchor="t"/>
+          <a:bodyPr xmlns:a="http://schemas.openxmlformats.org/drawingml/2006/main" wrap="square" lIns="18300" tIns="18300" rIns="18300" bIns="18300" anchor="t"/>
           <a:lstStyle xmlns:a="http://schemas.openxmlformats.org/drawingml/2006/main"/>
           <a:p xmlns:a="http://schemas.openxmlformats.org/drawingml/2006/main">
             <a:pPr algn="l">
               <a:lnSpc>
-                <a:spcPct val="108000"/>
+                <a:spcPct val="80000"/>
               </a:lnSpc>
               <a:buNone/>
               <a:defRPr sz="1058" b="1">
@@ -2558,7 +2536,7 @@
         </p:nvSpPr>
         <p:spPr>
           <a:xfrm xmlns:a="http://schemas.openxmlformats.org/drawingml/2006/main">
-            <a:off x="5810250" y="4705350"/>
+            <a:off x="5810250" y="4288155"/>
             <a:ext cx="1428750" cy="190500"/>
           </a:xfrm>
           <a:prstGeom xmlns:a="http://schemas.openxmlformats.org/drawingml/2006/main" prst="rect">
@@ -2571,12 +2549,12 @@
           </a:ln>
         </p:spPr>
         <p:txBody>
-          <a:bodyPr xmlns:a="http://schemas.openxmlformats.org/drawingml/2006/main" wrap="square" lIns="0" tIns="0" rIns="0" bIns="0" anchor="t"/>
+          <a:bodyPr xmlns:a="http://schemas.openxmlformats.org/drawingml/2006/main" wrap="square" lIns="18300" tIns="18300" rIns="18300" bIns="18300" anchor="t"/>
           <a:lstStyle xmlns:a="http://schemas.openxmlformats.org/drawingml/2006/main"/>
           <a:p xmlns:a="http://schemas.openxmlformats.org/drawingml/2006/main">
             <a:pPr algn="r">
               <a:lnSpc>
-                <a:spcPct val="108000"/>
+                <a:spcPct val="80000"/>
               </a:lnSpc>
               <a:buNone/>
               <a:defRPr sz="1058" b="1">
@@ -2618,8 +2596,8 @@
         </p:nvSpPr>
         <p:spPr>
           <a:xfrm xmlns:a="http://schemas.openxmlformats.org/drawingml/2006/main">
-            <a:off x="266700" y="4943475"/>
-            <a:ext cx="7000875" cy="457200"/>
+            <a:off x="266700" y="4478655"/>
+            <a:ext cx="7000875" cy="402336"/>
           </a:xfrm>
           <a:prstGeom xmlns:a="http://schemas.openxmlformats.org/drawingml/2006/main" prst="rect">
             <a:avLst/>
@@ -2631,16 +2609,13 @@
           </a:ln>
         </p:spPr>
         <p:txBody>
-          <a:bodyPr xmlns:a="http://schemas.openxmlformats.org/drawingml/2006/main" wrap="square" lIns="0" tIns="0" rIns="0" bIns="0" anchor="t"/>
+          <a:bodyPr xmlns:a="http://schemas.openxmlformats.org/drawingml/2006/main" wrap="square" lIns="18300" tIns="18300" rIns="18300" bIns="18300" anchor="t"/>
           <a:lstStyle xmlns:a="http://schemas.openxmlformats.org/drawingml/2006/main"/>
           <a:p xmlns:a="http://schemas.openxmlformats.org/drawingml/2006/main">
             <a:pPr marL="12" indent="-10" algn="l">
               <a:lnSpc>
-                <a:spcPct val="108000"/>
+                <a:spcPct val="80000"/>
               </a:lnSpc>
-              <a:spcAft>
-                <a:spcPts val="3"/>
-              </a:spcAft>
               <a:buNone/>
               <a:defRPr sz="953" b="0">
                 <a:solidFill>
@@ -2688,11 +2663,8 @@
           <a:p xmlns:a="http://schemas.openxmlformats.org/drawingml/2006/main">
             <a:pPr marL="12" indent="-10" algn="l">
               <a:lnSpc>
-                <a:spcPct val="108000"/>
+                <a:spcPct val="80000"/>
               </a:lnSpc>
-              <a:spcAft>
-                <a:spcPts val="3"/>
-              </a:spcAft>
               <a:buNone/>
               <a:defRPr sz="953" b="0">
                 <a:solidFill>
@@ -2755,7 +2727,7 @@
         </p:nvSpPr>
         <p:spPr>
           <a:xfrm xmlns:a="http://schemas.openxmlformats.org/drawingml/2006/main">
-            <a:off x="266700" y="5476875"/>
+            <a:off x="266700" y="4880991"/>
             <a:ext cx="2667000" cy="190500"/>
           </a:xfrm>
           <a:prstGeom xmlns:a="http://schemas.openxmlformats.org/drawingml/2006/main" prst="rect">
@@ -2768,12 +2740,12 @@
           </a:ln>
         </p:spPr>
         <p:txBody>
-          <a:bodyPr xmlns:a="http://schemas.openxmlformats.org/drawingml/2006/main" wrap="square" lIns="0" tIns="0" rIns="0" bIns="0" anchor="t"/>
+          <a:bodyPr xmlns:a="http://schemas.openxmlformats.org/drawingml/2006/main" wrap="square" lIns="18300" tIns="18300" rIns="18300" bIns="18300" anchor="t"/>
           <a:lstStyle xmlns:a="http://schemas.openxmlformats.org/drawingml/2006/main"/>
           <a:p xmlns:a="http://schemas.openxmlformats.org/drawingml/2006/main">
             <a:pPr algn="l">
               <a:lnSpc>
-                <a:spcPct val="108000"/>
+                <a:spcPct val="80000"/>
               </a:lnSpc>
               <a:buNone/>
               <a:defRPr sz="1200" b="1">
@@ -2815,7 +2787,7 @@
         </p:nvSpPr>
         <p:spPr>
           <a:xfrm xmlns:a="http://schemas.openxmlformats.org/drawingml/2006/main">
-            <a:off x="266700" y="5695950"/>
+            <a:off x="266700" y="5076491"/>
             <a:ext cx="7239000" cy="20955"/>
           </a:xfrm>
           <a:prstGeom xmlns:a="http://schemas.openxmlformats.org/drawingml/2006/main" prst="rect">
@@ -2848,7 +2820,7 @@
         </p:nvSpPr>
         <p:spPr>
           <a:xfrm xmlns:a="http://schemas.openxmlformats.org/drawingml/2006/main">
-            <a:off x="266700" y="5772150"/>
+            <a:off x="266700" y="5092446"/>
             <a:ext cx="4953000" cy="190500"/>
           </a:xfrm>
           <a:prstGeom xmlns:a="http://schemas.openxmlformats.org/drawingml/2006/main" prst="rect">
@@ -2861,12 +2833,12 @@
           </a:ln>
         </p:spPr>
         <p:txBody>
-          <a:bodyPr xmlns:a="http://schemas.openxmlformats.org/drawingml/2006/main" wrap="square" lIns="0" tIns="0" rIns="0" bIns="0" anchor="t"/>
+          <a:bodyPr xmlns:a="http://schemas.openxmlformats.org/drawingml/2006/main" wrap="square" lIns="18300" tIns="18300" rIns="18300" bIns="18300" anchor="t"/>
           <a:lstStyle xmlns:a="http://schemas.openxmlformats.org/drawingml/2006/main"/>
           <a:p xmlns:a="http://schemas.openxmlformats.org/drawingml/2006/main">
             <a:pPr algn="l">
               <a:lnSpc>
-                <a:spcPct val="108000"/>
+                <a:spcPct val="80000"/>
               </a:lnSpc>
               <a:buNone/>
               <a:defRPr sz="1058" b="1">
@@ -2887,7 +2859,1073 @@
                 <a:ea typeface="Arial"/>
                 <a:cs typeface="Arial"/>
               </a:rPr>
-              <a:t>宿舍零食箱运营项目</a:t>
+              <a:t>技术项目经验</a:t>
+            </a:r>
+          </a:p>
+        </p:txBody>
+      </p:sp>
+      <p:sp>
+        <p:nvSpPr>
+          <p:cNvPr id="27" name="">
+            <a:extLst xmlns:a="http://schemas.openxmlformats.org/drawingml/2006/main">
+              <a:ext uri="{FF2B5EF4-FFF2-40B4-BE49-F238E27FC236}">
+                <a16:creationId xmlns:a16="http://schemas.microsoft.com/office/drawing/2014/main" id="{23973BF4-0F4A-47F4-A3BB-9CAF2085E38E}"/>
+              </a:ext>
+            </a:extLst>
+          </p:cNvPr>
+          <p:cNvSpPr>
+            <a:spLocks xmlns:a="http://schemas.openxmlformats.org/drawingml/2006/main" noGrp="1"/>
+          </p:cNvSpPr>
+          <p:nvPr/>
+        </p:nvSpPr>
+        <p:spPr>
+          <a:xfrm xmlns:a="http://schemas.openxmlformats.org/drawingml/2006/main">
+            <a:off x="266700" y="5282946"/>
+            <a:ext cx="7000875" cy="220000"/>
+          </a:xfrm>
+          <a:prstGeom xmlns:a="http://schemas.openxmlformats.org/drawingml/2006/main" prst="rect">
+            <a:avLst/>
+          </a:prstGeom>
+          <a:noFill xmlns:a="http://schemas.openxmlformats.org/drawingml/2006/main"/>
+          <a:ln xmlns:a="http://schemas.openxmlformats.org/drawingml/2006/main" w="0">
+            <a:noFill/>
+            <a:prstDash val="solid"/>
+          </a:ln>
+        </p:spPr>
+        <p:txBody>
+          <a:bodyPr xmlns:a="http://schemas.openxmlformats.org/drawingml/2006/main" wrap="square" lIns="18300" tIns="18300" rIns="18300" bIns="18300" anchor="t"/>
+          <a:lstStyle xmlns:a="http://schemas.openxmlformats.org/drawingml/2006/main"/>
+          <a:p xmlns:a="http://schemas.openxmlformats.org/drawingml/2006/main">
+            <a:pPr marL="12" indent="-10" algn="l">
+              <a:lnSpc>
+                <a:spcPct val="80000"/>
+              </a:lnSpc>
+              <a:buNone/>
+              <a:defRPr sz="900" b="0">
+                <a:solidFill>
+                  <a:srgbClr val="111111"/>
+                </a:solidFill>
+                <a:latin typeface="Arial"/>
+                <a:ea typeface="Arial"/>
+                <a:cs typeface="Arial"/>
+              </a:defRPr>
+            </a:pPr>
+            <a:r>
+              <a:rPr sz="900">
+                <a:solidFill>
+                  <a:srgbClr val="111111"/>
+                </a:solidFill>
+                <a:latin typeface="Arial"/>
+                <a:ea typeface="Arial"/>
+                <a:cs typeface="Arial"/>
+              </a:rPr>
+              <a:t>• </a:t>
+            </a:r>
+            <a:r>
+              <a:rPr sz="900" b="1">
+                <a:solidFill>
+                  <a:srgbClr val="111111"/>
+                </a:solidFill>
+                <a:latin typeface="Arial"/>
+                <a:ea typeface="Arial"/>
+                <a:cs typeface="Arial"/>
+              </a:rPr>
+              <a:t>Hermes MCP Adapter：</a:t>
+            </a:r>
+            <a:r>
+              <a:rPr sz="900">
+                <a:solidFill>
+                  <a:srgbClr val="111111"/>
+                </a:solidFill>
+                <a:latin typeface="Arial"/>
+                <a:ea typeface="Arial"/>
+                <a:cs typeface="Arial"/>
+              </a:rPr>
+              <a:t>开发 AI Agent MCP 工具调用层，注册 9 个自定义工具，对接 Telegram / iMessage 多平台消息路由，systemd + Nginx 生产部署。</a:t>
+            </a:r>
+          </a:p>
+        </p:txBody>
+      </p:sp>
+      <p:sp>
+        <p:nvSpPr>
+          <p:cNvPr id="27" name="">
+            <a:extLst xmlns:a="http://schemas.openxmlformats.org/drawingml/2006/main">
+              <a:ext uri="{FF2B5EF4-FFF2-40B4-BE49-F238E27FC236}">
+                <a16:creationId xmlns:a16="http://schemas.microsoft.com/office/drawing/2014/main" id="{23973BF4-0F4A-47F4-A3BB-9CAF2085E38E}"/>
+              </a:ext>
+            </a:extLst>
+          </p:cNvPr>
+          <p:cNvSpPr>
+            <a:spLocks xmlns:a="http://schemas.openxmlformats.org/drawingml/2006/main" noGrp="1"/>
+          </p:cNvSpPr>
+          <p:nvPr/>
+        </p:nvSpPr>
+        <p:spPr>
+          <a:xfrm xmlns:a="http://schemas.openxmlformats.org/drawingml/2006/main">
+            <a:off x="266700" y="5528346"/>
+            <a:ext cx="7000875" cy="220000"/>
+          </a:xfrm>
+          <a:prstGeom xmlns:a="http://schemas.openxmlformats.org/drawingml/2006/main" prst="rect">
+            <a:avLst/>
+          </a:prstGeom>
+          <a:noFill xmlns:a="http://schemas.openxmlformats.org/drawingml/2006/main"/>
+          <a:ln xmlns:a="http://schemas.openxmlformats.org/drawingml/2006/main" w="0">
+            <a:noFill/>
+            <a:prstDash val="solid"/>
+          </a:ln>
+        </p:spPr>
+        <p:txBody>
+          <a:bodyPr xmlns:a="http://schemas.openxmlformats.org/drawingml/2006/main" wrap="square" lIns="18300" tIns="18300" rIns="18300" bIns="18300" anchor="t"/>
+          <a:lstStyle xmlns:a="http://schemas.openxmlformats.org/drawingml/2006/main"/>
+          <a:p xmlns:a="http://schemas.openxmlformats.org/drawingml/2006/main">
+            <a:pPr marL="12" indent="-10" algn="l">
+              <a:lnSpc>
+                <a:spcPct val="80000"/>
+              </a:lnSpc>
+              <a:buNone/>
+              <a:defRPr sz="900" b="0">
+                <a:solidFill>
+                  <a:srgbClr val="111111"/>
+                </a:solidFill>
+                <a:latin typeface="Arial"/>
+                <a:ea typeface="Arial"/>
+                <a:cs typeface="Arial"/>
+              </a:defRPr>
+            </a:pPr>
+            <a:r>
+              <a:rPr sz="900">
+                <a:solidFill>
+                  <a:srgbClr val="111111"/>
+                </a:solidFill>
+                <a:latin typeface="Arial"/>
+                <a:ea typeface="Arial"/>
+                <a:cs typeface="Arial"/>
+              </a:rPr>
+              <a:t>• </a:t>
+            </a:r>
+            <a:r>
+              <a:rPr sz="900" b="1">
+                <a:solidFill>
+                  <a:srgbClr val="111111"/>
+                </a:solidFill>
+                <a:latin typeface="Arial"/>
+                <a:ea typeface="Arial"/>
+                <a:cs typeface="Arial"/>
+              </a:rPr>
+              <a:t>CodeIsland 远程会话监控：</a:t>
+            </a:r>
+            <a:r>
+              <a:rPr sz="900">
+                <a:solidFill>
+                  <a:srgbClr val="111111"/>
+                </a:solidFill>
+                <a:latin typeface="Arial"/>
+                <a:ea typeface="Arial"/>
+                <a:cs typeface="Arial"/>
+              </a:rPr>
+              <a:t>基于 Claude Code CLI 开发 SSH 中继与远程会话监控，实时捕获终端输出，以 JSON + SQLite 支持回溯分析及子进程生命周期管理。</a:t>
+            </a:r>
+          </a:p>
+        </p:txBody>
+      </p:sp>
+      <p:sp>
+        <p:nvSpPr>
+          <p:cNvPr id="27" name="">
+            <a:extLst xmlns:a="http://schemas.openxmlformats.org/drawingml/2006/main">
+              <a:ext uri="{FF2B5EF4-FFF2-40B4-BE49-F238E27FC236}">
+                <a16:creationId xmlns:a16="http://schemas.microsoft.com/office/drawing/2014/main" id="{23973BF4-0F4A-47F4-A3BB-9CAF2085E38E}"/>
+              </a:ext>
+            </a:extLst>
+          </p:cNvPr>
+          <p:cNvSpPr>
+            <a:spLocks xmlns:a="http://schemas.openxmlformats.org/drawingml/2006/main" noGrp="1"/>
+          </p:cNvSpPr>
+          <p:nvPr/>
+        </p:nvSpPr>
+        <p:spPr>
+          <a:xfrm xmlns:a="http://schemas.openxmlformats.org/drawingml/2006/main">
+            <a:off x="266700" y="5773746"/>
+            <a:ext cx="7000875" cy="220000"/>
+          </a:xfrm>
+          <a:prstGeom xmlns:a="http://schemas.openxmlformats.org/drawingml/2006/main" prst="rect">
+            <a:avLst/>
+          </a:prstGeom>
+          <a:noFill xmlns:a="http://schemas.openxmlformats.org/drawingml/2006/main"/>
+          <a:ln xmlns:a="http://schemas.openxmlformats.org/drawingml/2006/main" w="0">
+            <a:noFill/>
+            <a:prstDash val="solid"/>
+          </a:ln>
+        </p:spPr>
+        <p:txBody>
+          <a:bodyPr xmlns:a="http://schemas.openxmlformats.org/drawingml/2006/main" wrap="square" lIns="18300" tIns="18300" rIns="18300" bIns="18300" anchor="t"/>
+          <a:lstStyle xmlns:a="http://schemas.openxmlformats.org/drawingml/2006/main"/>
+          <a:p xmlns:a="http://schemas.openxmlformats.org/drawingml/2006/main">
+            <a:pPr marL="12" indent="-10" algn="l">
+              <a:lnSpc>
+                <a:spcPct val="80000"/>
+              </a:lnSpc>
+              <a:buNone/>
+              <a:defRPr sz="900" b="0">
+                <a:solidFill>
+                  <a:srgbClr val="111111"/>
+                </a:solidFill>
+                <a:latin typeface="Arial"/>
+                <a:ea typeface="Arial"/>
+                <a:cs typeface="Arial"/>
+              </a:defRPr>
+            </a:pPr>
+            <a:r>
+              <a:rPr sz="900">
+                <a:solidFill>
+                  <a:srgbClr val="111111"/>
+                </a:solidFill>
+                <a:latin typeface="Arial"/>
+                <a:ea typeface="Arial"/>
+                <a:cs typeface="Arial"/>
+              </a:rPr>
+              <a:t>• </a:t>
+            </a:r>
+            <a:r>
+              <a:rPr sz="900" b="1">
+                <a:solidFill>
+                  <a:srgbClr val="111111"/>
+                </a:solidFill>
+                <a:latin typeface="Arial"/>
+                <a:ea typeface="Arial"/>
+                <a:cs typeface="Arial"/>
+              </a:rPr>
+              <a:t>英雄联盟数据平台：</a:t>
+            </a:r>
+            <a:r>
+              <a:rPr sz="900">
+                <a:solidFill>
+                  <a:srgbClr val="111111"/>
+                </a:solidFill>
+                <a:latin typeface="Arial"/>
+                <a:ea typeface="Arial"/>
+                <a:cs typeface="Arial"/>
+              </a:rPr>
+              <a:t>通过 Riot Games API 监控服务器状态与排位数据，并以 Node.js + Telegram Bot 推送告警；使用 FastAPI + React 构建 RecapLoL 复盘与 AI 教练报告。</a:t>
+            </a:r>
+          </a:p>
+        </p:txBody>
+      </p:sp>
+      <p:sp>
+        <p:nvSpPr>
+          <p:cNvPr id="27" name="">
+            <a:extLst xmlns:a="http://schemas.openxmlformats.org/drawingml/2006/main">
+              <a:ext uri="{FF2B5EF4-FFF2-40B4-BE49-F238E27FC236}">
+                <a16:creationId xmlns:a16="http://schemas.microsoft.com/office/drawing/2014/main" id="{23973BF4-0F4A-47F4-A3BB-9CAF2085E38E}"/>
+              </a:ext>
+            </a:extLst>
+          </p:cNvPr>
+          <p:cNvSpPr>
+            <a:spLocks xmlns:a="http://schemas.openxmlformats.org/drawingml/2006/main" noGrp="1"/>
+          </p:cNvSpPr>
+          <p:nvPr/>
+        </p:nvSpPr>
+        <p:spPr>
+          <a:xfrm xmlns:a="http://schemas.openxmlformats.org/drawingml/2006/main">
+            <a:off x="266700" y="6019146"/>
+            <a:ext cx="7000875" cy="220000"/>
+          </a:xfrm>
+          <a:prstGeom xmlns:a="http://schemas.openxmlformats.org/drawingml/2006/main" prst="rect">
+            <a:avLst/>
+          </a:prstGeom>
+          <a:noFill xmlns:a="http://schemas.openxmlformats.org/drawingml/2006/main"/>
+          <a:ln xmlns:a="http://schemas.openxmlformats.org/drawingml/2006/main" w="0">
+            <a:noFill/>
+            <a:prstDash val="solid"/>
+          </a:ln>
+        </p:spPr>
+        <p:txBody>
+          <a:bodyPr xmlns:a="http://schemas.openxmlformats.org/drawingml/2006/main" wrap="square" lIns="18300" tIns="18300" rIns="18300" bIns="18300" anchor="t"/>
+          <a:lstStyle xmlns:a="http://schemas.openxmlformats.org/drawingml/2006/main"/>
+          <a:p xmlns:a="http://schemas.openxmlformats.org/drawingml/2006/main">
+            <a:pPr marL="12" indent="-10" algn="l">
+              <a:lnSpc>
+                <a:spcPct val="80000"/>
+              </a:lnSpc>
+              <a:buNone/>
+              <a:defRPr sz="900" b="0">
+                <a:solidFill>
+                  <a:srgbClr val="111111"/>
+                </a:solidFill>
+                <a:latin typeface="Arial"/>
+                <a:ea typeface="Arial"/>
+                <a:cs typeface="Arial"/>
+              </a:defRPr>
+            </a:pPr>
+            <a:r>
+              <a:rPr sz="900">
+                <a:solidFill>
+                  <a:srgbClr val="111111"/>
+                </a:solidFill>
+                <a:latin typeface="Arial"/>
+                <a:ea typeface="Arial"/>
+                <a:cs typeface="Arial"/>
+              </a:rPr>
+              <a:t>• </a:t>
+            </a:r>
+            <a:r>
+              <a:rPr sz="900" b="1">
+                <a:solidFill>
+                  <a:srgbClr val="111111"/>
+                </a:solidFill>
+                <a:latin typeface="Arial"/>
+                <a:ea typeface="Arial"/>
+                <a:cs typeface="Arial"/>
+              </a:rPr>
+              <a:t>geekgeekrun-mcp：</a:t>
+            </a:r>
+            <a:r>
+              <a:rPr sz="900">
+                <a:solidFill>
+                  <a:srgbClr val="111111"/>
+                </a:solidFill>
+                <a:latin typeface="Arial"/>
+                <a:ea typeface="Arial"/>
+                <a:cs typeface="Arial"/>
+              </a:rPr>
+              <a:t>为 GeekGeekRun 的 BOSS 直聘自动开聊流程开发 MCP 接口，使 AI Agent 能调用职位检索、沟通与求职流程自动化能力。</a:t>
+            </a:r>
+          </a:p>
+        </p:txBody>
+      </p:sp>
+      <p:sp>
+        <p:nvSpPr>
+          <p:cNvPr id="38" name="Project 5">
+            <a:extLst xmlns:a="http://schemas.openxmlformats.org/drawingml/2006/main">
+              <a:ext uri="{FF2B5EF4-FFF2-40B4-BE49-F238E27FC236}">
+                <a16:creationId xmlns:a16="http://schemas.microsoft.com/office/drawing/2014/main" id="{23973BF4-0F4A-47F4-A3BB-9CAF2085E38E}"/>
+              </a:ext>
+            </a:extLst>
+          </p:cNvPr>
+          <p:cNvSpPr>
+            <a:spLocks xmlns:a="http://schemas.openxmlformats.org/drawingml/2006/main" noGrp="1"/>
+          </p:cNvSpPr>
+          <p:nvPr/>
+        </p:nvSpPr>
+        <p:spPr>
+          <a:xfrm xmlns:a="http://schemas.openxmlformats.org/drawingml/2006/main">
+            <a:off x="266700" y="6264546"/>
+            <a:ext cx="7000875" cy="220000"/>
+          </a:xfrm>
+          <a:prstGeom xmlns:a="http://schemas.openxmlformats.org/drawingml/2006/main" prst="rect">
+            <a:avLst/>
+          </a:prstGeom>
+          <a:noFill xmlns:a="http://schemas.openxmlformats.org/drawingml/2006/main"/>
+          <a:ln xmlns:a="http://schemas.openxmlformats.org/drawingml/2006/main" w="0">
+            <a:noFill/>
+            <a:prstDash val="solid"/>
+          </a:ln>
+        </p:spPr>
+        <p:txBody>
+          <a:bodyPr xmlns:a="http://schemas.openxmlformats.org/drawingml/2006/main" wrap="square" lIns="18300" tIns="18300" rIns="18300" bIns="18300" anchor="t"/>
+          <a:lstStyle xmlns:a="http://schemas.openxmlformats.org/drawingml/2006/main"/>
+          <a:p xmlns:a="http://schemas.openxmlformats.org/drawingml/2006/main">
+            <a:pPr marL="12" indent="-10" algn="l">
+              <a:lnSpc>
+                <a:spcPct val="80000"/>
+              </a:lnSpc>
+              <a:buNone/>
+              <a:defRPr sz="900" b="0">
+                <a:solidFill>
+                  <a:srgbClr val="111111"/>
+                </a:solidFill>
+                <a:latin typeface="Arial"/>
+                <a:ea typeface="Arial"/>
+                <a:cs typeface="Arial"/>
+              </a:defRPr>
+            </a:pPr>
+            <a:r>
+              <a:rPr sz="900">
+                <a:solidFill>
+                  <a:srgbClr val="111111"/>
+                </a:solidFill>
+                <a:latin typeface="Arial"/>
+                <a:ea typeface="Arial"/>
+                <a:cs typeface="Arial"/>
+              </a:rPr>
+              <a:t>• </a:t>
+            </a:r>
+            <a:r>
+              <a:rPr sz="900" b="1">
+                <a:solidFill>
+                  <a:srgbClr val="111111"/>
+                </a:solidFill>
+                <a:latin typeface="Arial"/>
+                <a:ea typeface="Arial"/>
+                <a:cs typeface="Arial"/>
+              </a:rPr>
+              <a:t>Projects Community：</a:t>
+            </a:r>
+            <a:r>
+              <a:rPr sz="900">
+                <a:solidFill>
+                  <a:srgbClr val="111111"/>
+                </a:solidFill>
+                <a:latin typeface="Arial"/>
+                <a:ea typeface="Arial"/>
+                <a:cs typeface="Arial"/>
+              </a:rPr>
+              <a:t>使用 Next.js 15 + SQLite + Drizzle + Vercel AI SDK 构建本地优先的游戏化研究工作台，集成 AI Realizer、社区地图与结构化决策。</a:t>
+            </a:r>
+          </a:p>
+        </p:txBody>
+      </p:sp>
+      <p:sp>
+        <p:nvSpPr>
+          <p:cNvPr id="28" name="">
+            <a:extLst xmlns:a="http://schemas.openxmlformats.org/drawingml/2006/main">
+              <a:ext uri="{FF2B5EF4-FFF2-40B4-BE49-F238E27FC236}">
+                <a16:creationId xmlns:a16="http://schemas.microsoft.com/office/drawing/2014/main" id="{F5921FB4-43DC-4E59-A504-3924B9EF9D58}"/>
+              </a:ext>
+            </a:extLst>
+          </p:cNvPr>
+          <p:cNvSpPr>
+            <a:spLocks xmlns:a="http://schemas.openxmlformats.org/drawingml/2006/main" noGrp="1"/>
+          </p:cNvSpPr>
+          <p:nvPr/>
+        </p:nvSpPr>
+        <p:spPr>
+          <a:xfrm xmlns:a="http://schemas.openxmlformats.org/drawingml/2006/main">
+            <a:off x="266700" y="6484546"/>
+            <a:ext cx="2667000" cy="190500"/>
+          </a:xfrm>
+          <a:prstGeom xmlns:a="http://schemas.openxmlformats.org/drawingml/2006/main" prst="rect">
+            <a:avLst/>
+          </a:prstGeom>
+          <a:noFill xmlns:a="http://schemas.openxmlformats.org/drawingml/2006/main"/>
+          <a:ln xmlns:a="http://schemas.openxmlformats.org/drawingml/2006/main" w="0">
+            <a:noFill/>
+            <a:prstDash val="solid"/>
+          </a:ln>
+        </p:spPr>
+        <p:txBody>
+          <a:bodyPr xmlns:a="http://schemas.openxmlformats.org/drawingml/2006/main" wrap="square" lIns="18300" tIns="18300" rIns="18300" bIns="18300" anchor="t"/>
+          <a:lstStyle xmlns:a="http://schemas.openxmlformats.org/drawingml/2006/main"/>
+          <a:p xmlns:a="http://schemas.openxmlformats.org/drawingml/2006/main">
+            <a:pPr algn="l">
+              <a:lnSpc>
+                <a:spcPct val="80000"/>
+              </a:lnSpc>
+              <a:buNone/>
+              <a:defRPr sz="1200" b="1">
+                <a:solidFill>
+                  <a:srgbClr val="000000"/>
+                </a:solidFill>
+                <a:latin typeface="Arial"/>
+                <a:ea typeface="Arial"/>
+                <a:cs typeface="Arial"/>
+              </a:defRPr>
+            </a:pPr>
+            <a:r>
+              <a:rPr sz="1200" b="1">
+                <a:solidFill>
+                  <a:srgbClr val="000000"/>
+                </a:solidFill>
+                <a:latin typeface="Arial"/>
+                <a:ea typeface="Arial"/>
+                <a:cs typeface="Arial"/>
+              </a:rPr>
+              <a:t>素质能力</a:t>
+            </a:r>
+          </a:p>
+        </p:txBody>
+      </p:sp>
+      <p:sp>
+        <p:nvSpPr>
+          <p:cNvPr id="29" name="">
+            <a:extLst xmlns:a="http://schemas.openxmlformats.org/drawingml/2006/main">
+              <a:ext uri="{FF2B5EF4-FFF2-40B4-BE49-F238E27FC236}">
+                <a16:creationId xmlns:a16="http://schemas.microsoft.com/office/drawing/2014/main" id="{C6D3A077-C816-4E7A-AF71-32BEEA63064A}"/>
+              </a:ext>
+            </a:extLst>
+          </p:cNvPr>
+          <p:cNvSpPr>
+            <a:spLocks xmlns:a="http://schemas.openxmlformats.org/drawingml/2006/main" noGrp="1"/>
+          </p:cNvSpPr>
+          <p:nvPr/>
+        </p:nvSpPr>
+        <p:spPr>
+          <a:xfrm xmlns:a="http://schemas.openxmlformats.org/drawingml/2006/main">
+            <a:off x="266700" y="6680046"/>
+            <a:ext cx="7239000" cy="20955"/>
+          </a:xfrm>
+          <a:prstGeom xmlns:a="http://schemas.openxmlformats.org/drawingml/2006/main" prst="rect">
+            <a:avLst/>
+          </a:prstGeom>
+          <a:solidFill xmlns:a="http://schemas.openxmlformats.org/drawingml/2006/main">
+            <a:srgbClr val="000000"/>
+          </a:solidFill>
+          <a:ln xmlns:a="http://schemas.openxmlformats.org/drawingml/2006/main" w="0">
+            <a:solidFill>
+              <a:srgbClr val="000000"/>
+            </a:solidFill>
+            <a:prstDash val="solid"/>
+          </a:ln>
+        </p:spPr>
+      </p:sp>
+      <p:sp>
+        <p:nvSpPr>
+          <p:cNvPr id="30" name="">
+            <a:extLst xmlns:a="http://schemas.openxmlformats.org/drawingml/2006/main">
+              <a:ext uri="{FF2B5EF4-FFF2-40B4-BE49-F238E27FC236}">
+                <a16:creationId xmlns:a16="http://schemas.microsoft.com/office/drawing/2014/main" id="{12709166-4620-4276-9D27-47C9C96D523D}"/>
+              </a:ext>
+            </a:extLst>
+          </p:cNvPr>
+          <p:cNvSpPr>
+            <a:spLocks xmlns:a="http://schemas.openxmlformats.org/drawingml/2006/main" noGrp="1"/>
+          </p:cNvSpPr>
+          <p:nvPr/>
+        </p:nvSpPr>
+        <p:spPr>
+          <a:xfrm xmlns:a="http://schemas.openxmlformats.org/drawingml/2006/main">
+            <a:off x="266700" y="6701001"/>
+            <a:ext cx="7000875" cy="160000"/>
+          </a:xfrm>
+          <a:prstGeom xmlns:a="http://schemas.openxmlformats.org/drawingml/2006/main" prst="rect">
+            <a:avLst/>
+          </a:prstGeom>
+          <a:noFill xmlns:a="http://schemas.openxmlformats.org/drawingml/2006/main"/>
+          <a:ln xmlns:a="http://schemas.openxmlformats.org/drawingml/2006/main" w="0">
+            <a:noFill/>
+            <a:prstDash val="solid"/>
+          </a:ln>
+        </p:spPr>
+        <p:txBody>
+          <a:bodyPr xmlns:a="http://schemas.openxmlformats.org/drawingml/2006/main" wrap="square" lIns="18300" tIns="18300" rIns="18300" bIns="18300" anchor="t"/>
+          <a:lstStyle xmlns:a="http://schemas.openxmlformats.org/drawingml/2006/main"/>
+          <a:p xmlns:a="http://schemas.openxmlformats.org/drawingml/2006/main">
+            <a:pPr marL="12" indent="-10" algn="l">
+              <a:lnSpc>
+                <a:spcPct val="80000"/>
+              </a:lnSpc>
+              <a:buNone/>
+              <a:defRPr sz="953" b="0">
+                <a:solidFill>
+                  <a:srgbClr val="111111"/>
+                </a:solidFill>
+                <a:latin typeface="Arial"/>
+                <a:ea typeface="Arial"/>
+                <a:cs typeface="Arial"/>
+              </a:defRPr>
+            </a:pPr>
+            <a:r>
+              <a:rPr sz="953">
+                <a:solidFill>
+                  <a:srgbClr val="111111"/>
+                </a:solidFill>
+                <a:latin typeface="Arial"/>
+                <a:ea typeface="Arial"/>
+                <a:cs typeface="Arial"/>
+              </a:rPr>
+              <a:t>• </a:t>
+            </a:r>
+            <a:r>
+              <a:rPr sz="953" b="1">
+                <a:solidFill>
+                  <a:srgbClr val="111111"/>
+                </a:solidFill>
+                <a:latin typeface="Arial"/>
+                <a:ea typeface="Arial"/>
+                <a:cs typeface="Arial"/>
+              </a:rPr>
+              <a:t>语言水平：</a:t>
+            </a:r>
+            <a:r>
+              <a:rPr sz="953">
+                <a:solidFill>
+                  <a:srgbClr val="111111"/>
+                </a:solidFill>
+                <a:latin typeface="Arial"/>
+                <a:ea typeface="Arial"/>
+                <a:cs typeface="Arial"/>
+              </a:rPr>
+              <a:t>雅思 6.0；英语具备职业工作能力；普通话、粤语母语 / 双语。</a:t>
+            </a:r>
+          </a:p>
+        </p:txBody>
+      </p:sp>
+      <p:sp>
+        <p:nvSpPr>
+          <p:cNvPr id="30" name="">
+            <a:extLst xmlns:a="http://schemas.openxmlformats.org/drawingml/2006/main">
+              <a:ext uri="{FF2B5EF4-FFF2-40B4-BE49-F238E27FC236}">
+                <a16:creationId xmlns:a16="http://schemas.microsoft.com/office/drawing/2014/main" id="{12709166-4620-4276-9D27-47C9C96D523D}"/>
+              </a:ext>
+            </a:extLst>
+          </p:cNvPr>
+          <p:cNvSpPr>
+            <a:spLocks xmlns:a="http://schemas.openxmlformats.org/drawingml/2006/main" noGrp="1"/>
+          </p:cNvSpPr>
+          <p:nvPr/>
+        </p:nvSpPr>
+        <p:spPr>
+          <a:xfrm xmlns:a="http://schemas.openxmlformats.org/drawingml/2006/main">
+            <a:off x="266700" y="6886401"/>
+            <a:ext cx="7000875" cy="160000"/>
+          </a:xfrm>
+          <a:prstGeom xmlns:a="http://schemas.openxmlformats.org/drawingml/2006/main" prst="rect">
+            <a:avLst/>
+          </a:prstGeom>
+          <a:noFill xmlns:a="http://schemas.openxmlformats.org/drawingml/2006/main"/>
+          <a:ln xmlns:a="http://schemas.openxmlformats.org/drawingml/2006/main" w="0">
+            <a:noFill/>
+            <a:prstDash val="solid"/>
+          </a:ln>
+        </p:spPr>
+        <p:txBody>
+          <a:bodyPr xmlns:a="http://schemas.openxmlformats.org/drawingml/2006/main" wrap="square" lIns="18300" tIns="18300" rIns="18300" bIns="18300" anchor="t"/>
+          <a:lstStyle xmlns:a="http://schemas.openxmlformats.org/drawingml/2006/main"/>
+          <a:p xmlns:a="http://schemas.openxmlformats.org/drawingml/2006/main">
+            <a:pPr marL="12" indent="-10" algn="l">
+              <a:lnSpc>
+                <a:spcPct val="80000"/>
+              </a:lnSpc>
+              <a:buNone/>
+              <a:defRPr sz="953" b="0">
+                <a:solidFill>
+                  <a:srgbClr val="111111"/>
+                </a:solidFill>
+                <a:latin typeface="Arial"/>
+                <a:ea typeface="Arial"/>
+                <a:cs typeface="Arial"/>
+              </a:defRPr>
+            </a:pPr>
+            <a:r>
+              <a:rPr sz="953">
+                <a:solidFill>
+                  <a:srgbClr val="111111"/>
+                </a:solidFill>
+                <a:latin typeface="Arial"/>
+                <a:ea typeface="Arial"/>
+                <a:cs typeface="Arial"/>
+              </a:rPr>
+              <a:t>• </a:t>
+            </a:r>
+            <a:r>
+              <a:rPr sz="953" b="1">
+                <a:solidFill>
+                  <a:srgbClr val="111111"/>
+                </a:solidFill>
+                <a:latin typeface="Arial"/>
+                <a:ea typeface="Arial"/>
+                <a:cs typeface="Arial"/>
+              </a:rPr>
+              <a:t>专业技能：</a:t>
+            </a:r>
+            <a:r>
+              <a:rPr sz="953">
+                <a:solidFill>
+                  <a:srgbClr val="111111"/>
+                </a:solidFill>
+                <a:latin typeface="Arial"/>
+                <a:ea typeface="Arial"/>
+                <a:cs typeface="Arial"/>
+              </a:rPr>
+              <a:t>具备材料检测基础、质量意识、技术文档写作、项目协调与执行能力。</a:t>
+            </a:r>
+          </a:p>
+        </p:txBody>
+      </p:sp>
+      <p:sp>
+        <p:nvSpPr>
+          <p:cNvPr id="30" name="">
+            <a:extLst xmlns:a="http://schemas.openxmlformats.org/drawingml/2006/main">
+              <a:ext uri="{FF2B5EF4-FFF2-40B4-BE49-F238E27FC236}">
+                <a16:creationId xmlns:a16="http://schemas.microsoft.com/office/drawing/2014/main" id="{12709166-4620-4276-9D27-47C9C96D523D}"/>
+              </a:ext>
+            </a:extLst>
+          </p:cNvPr>
+          <p:cNvSpPr>
+            <a:spLocks xmlns:a="http://schemas.openxmlformats.org/drawingml/2006/main" noGrp="1"/>
+          </p:cNvSpPr>
+          <p:nvPr/>
+        </p:nvSpPr>
+        <p:spPr>
+          <a:xfrm xmlns:a="http://schemas.openxmlformats.org/drawingml/2006/main">
+            <a:off x="266700" y="7071801"/>
+            <a:ext cx="7000875" cy="160000"/>
+          </a:xfrm>
+          <a:prstGeom xmlns:a="http://schemas.openxmlformats.org/drawingml/2006/main" prst="rect">
+            <a:avLst/>
+          </a:prstGeom>
+          <a:noFill xmlns:a="http://schemas.openxmlformats.org/drawingml/2006/main"/>
+          <a:ln xmlns:a="http://schemas.openxmlformats.org/drawingml/2006/main" w="0">
+            <a:noFill/>
+            <a:prstDash val="solid"/>
+          </a:ln>
+        </p:spPr>
+        <p:txBody>
+          <a:bodyPr xmlns:a="http://schemas.openxmlformats.org/drawingml/2006/main" wrap="square" lIns="18300" tIns="18300" rIns="18300" bIns="18300" anchor="t"/>
+          <a:lstStyle xmlns:a="http://schemas.openxmlformats.org/drawingml/2006/main"/>
+          <a:p xmlns:a="http://schemas.openxmlformats.org/drawingml/2006/main">
+            <a:pPr marL="12" indent="-10" algn="l">
+              <a:lnSpc>
+                <a:spcPct val="80000"/>
+              </a:lnSpc>
+              <a:buNone/>
+              <a:defRPr sz="953" b="0">
+                <a:solidFill>
+                  <a:srgbClr val="111111"/>
+                </a:solidFill>
+                <a:latin typeface="Arial"/>
+                <a:ea typeface="Arial"/>
+                <a:cs typeface="Arial"/>
+              </a:defRPr>
+            </a:pPr>
+            <a:r>
+              <a:rPr sz="953">
+                <a:solidFill>
+                  <a:srgbClr val="111111"/>
+                </a:solidFill>
+                <a:latin typeface="Arial"/>
+                <a:ea typeface="Arial"/>
+                <a:cs typeface="Arial"/>
+              </a:rPr>
+              <a:t>• </a:t>
+            </a:r>
+            <a:r>
+              <a:rPr sz="953" b="1">
+                <a:solidFill>
+                  <a:srgbClr val="111111"/>
+                </a:solidFill>
+                <a:latin typeface="Arial"/>
+                <a:ea typeface="Arial"/>
+                <a:cs typeface="Arial"/>
+              </a:rPr>
+              <a:t>数据能力：</a:t>
+            </a:r>
+            <a:r>
+              <a:rPr sz="953">
+                <a:solidFill>
+                  <a:srgbClr val="111111"/>
+                </a:solidFill>
+                <a:latin typeface="Arial"/>
+                <a:ea typeface="Arial"/>
+                <a:cs typeface="Arial"/>
+              </a:rPr>
+              <a:t>具备数据分析与信息整理意识，能够使用数字化工具提升工作效率。</a:t>
+            </a:r>
+          </a:p>
+        </p:txBody>
+      </p:sp>
+      <p:sp>
+        <p:nvSpPr>
+          <p:cNvPr id="30" name="">
+            <a:extLst xmlns:a="http://schemas.openxmlformats.org/drawingml/2006/main">
+              <a:ext uri="{FF2B5EF4-FFF2-40B4-BE49-F238E27FC236}">
+                <a16:creationId xmlns:a16="http://schemas.microsoft.com/office/drawing/2014/main" id="{12709166-4620-4276-9D27-47C9C96D523D}"/>
+              </a:ext>
+            </a:extLst>
+          </p:cNvPr>
+          <p:cNvSpPr>
+            <a:spLocks xmlns:a="http://schemas.openxmlformats.org/drawingml/2006/main" noGrp="1"/>
+          </p:cNvSpPr>
+          <p:nvPr/>
+        </p:nvSpPr>
+        <p:spPr>
+          <a:xfrm xmlns:a="http://schemas.openxmlformats.org/drawingml/2006/main">
+            <a:off x="266700" y="7257201"/>
+            <a:ext cx="7000875" cy="160000"/>
+          </a:xfrm>
+          <a:prstGeom xmlns:a="http://schemas.openxmlformats.org/drawingml/2006/main" prst="rect">
+            <a:avLst/>
+          </a:prstGeom>
+          <a:noFill xmlns:a="http://schemas.openxmlformats.org/drawingml/2006/main"/>
+          <a:ln xmlns:a="http://schemas.openxmlformats.org/drawingml/2006/main" w="0">
+            <a:noFill/>
+            <a:prstDash val="solid"/>
+          </a:ln>
+        </p:spPr>
+        <p:txBody>
+          <a:bodyPr xmlns:a="http://schemas.openxmlformats.org/drawingml/2006/main" wrap="square" lIns="18300" tIns="18300" rIns="18300" bIns="18300" anchor="t"/>
+          <a:lstStyle xmlns:a="http://schemas.openxmlformats.org/drawingml/2006/main"/>
+          <a:p xmlns:a="http://schemas.openxmlformats.org/drawingml/2006/main">
+            <a:pPr marL="12" indent="-10" algn="l">
+              <a:lnSpc>
+                <a:spcPct val="80000"/>
+              </a:lnSpc>
+              <a:buNone/>
+              <a:defRPr sz="953" b="0">
+                <a:solidFill>
+                  <a:srgbClr val="111111"/>
+                </a:solidFill>
+                <a:latin typeface="Arial"/>
+                <a:ea typeface="Arial"/>
+                <a:cs typeface="Arial"/>
+              </a:defRPr>
+            </a:pPr>
+            <a:r>
+              <a:rPr sz="953">
+                <a:solidFill>
+                  <a:srgbClr val="111111"/>
+                </a:solidFill>
+                <a:latin typeface="Arial"/>
+                <a:ea typeface="Arial"/>
+                <a:cs typeface="Arial"/>
+              </a:rPr>
+              <a:t>• </a:t>
+            </a:r>
+            <a:r>
+              <a:rPr sz="953" b="1">
+                <a:solidFill>
+                  <a:srgbClr val="111111"/>
+                </a:solidFill>
+                <a:latin typeface="Arial"/>
+                <a:ea typeface="Arial"/>
+                <a:cs typeface="Arial"/>
+              </a:rPr>
+              <a:t>证书许可：</a:t>
+            </a:r>
+            <a:r>
+              <a:rPr sz="953">
+                <a:solidFill>
+                  <a:srgbClr val="111111"/>
+                </a:solidFill>
+                <a:latin typeface="Arial"/>
+                <a:ea typeface="Arial"/>
+                <a:cs typeface="Arial"/>
+              </a:rPr>
+              <a:t>驾驶证；雅思 6.0。</a:t>
+            </a:r>
+          </a:p>
+        </p:txBody>
+      </p:sp>
+      <p:sp>
+        <p:nvSpPr>
+          <p:cNvPr id="30" name="">
+            <a:extLst xmlns:a="http://schemas.openxmlformats.org/drawingml/2006/main">
+              <a:ext uri="{FF2B5EF4-FFF2-40B4-BE49-F238E27FC236}">
+                <a16:creationId xmlns:a16="http://schemas.microsoft.com/office/drawing/2014/main" id="{12709166-4620-4276-9D27-47C9C96D523D}"/>
+              </a:ext>
+            </a:extLst>
+          </p:cNvPr>
+          <p:cNvSpPr>
+            <a:spLocks xmlns:a="http://schemas.openxmlformats.org/drawingml/2006/main" noGrp="1"/>
+          </p:cNvSpPr>
+          <p:nvPr/>
+        </p:nvSpPr>
+        <p:spPr>
+          <a:xfrm xmlns:a="http://schemas.openxmlformats.org/drawingml/2006/main">
+            <a:off x="266700" y="7442601"/>
+            <a:ext cx="7000875" cy="160000"/>
+          </a:xfrm>
+          <a:prstGeom xmlns:a="http://schemas.openxmlformats.org/drawingml/2006/main" prst="rect">
+            <a:avLst/>
+          </a:prstGeom>
+          <a:noFill xmlns:a="http://schemas.openxmlformats.org/drawingml/2006/main"/>
+          <a:ln xmlns:a="http://schemas.openxmlformats.org/drawingml/2006/main" w="0">
+            <a:noFill/>
+            <a:prstDash val="solid"/>
+          </a:ln>
+        </p:spPr>
+        <p:txBody>
+          <a:bodyPr xmlns:a="http://schemas.openxmlformats.org/drawingml/2006/main" wrap="square" lIns="18300" tIns="18300" rIns="18300" bIns="18300" anchor="t"/>
+          <a:lstStyle xmlns:a="http://schemas.openxmlformats.org/drawingml/2006/main"/>
+          <a:p xmlns:a="http://schemas.openxmlformats.org/drawingml/2006/main">
+            <a:pPr marL="12" indent="-10" algn="l">
+              <a:lnSpc>
+                <a:spcPct val="80000"/>
+              </a:lnSpc>
+              <a:buNone/>
+              <a:defRPr sz="953" b="0">
+                <a:solidFill>
+                  <a:srgbClr val="111111"/>
+                </a:solidFill>
+                <a:latin typeface="Arial"/>
+                <a:ea typeface="Arial"/>
+                <a:cs typeface="Arial"/>
+              </a:defRPr>
+            </a:pPr>
+            <a:r>
+              <a:rPr sz="953">
+                <a:solidFill>
+                  <a:srgbClr val="111111"/>
+                </a:solidFill>
+                <a:latin typeface="Arial"/>
+                <a:ea typeface="Arial"/>
+                <a:cs typeface="Arial"/>
+              </a:rPr>
+              <a:t>• </a:t>
+            </a:r>
+            <a:r>
+              <a:rPr sz="953" b="1">
+                <a:solidFill>
+                  <a:srgbClr val="111111"/>
+                </a:solidFill>
+                <a:latin typeface="Arial"/>
+                <a:ea typeface="Arial"/>
+                <a:cs typeface="Arial"/>
+              </a:rPr>
+              <a:t>个人链接：</a:t>
+            </a:r>
+            <a:r>
+              <a:rPr sz="953">
+                <a:solidFill>
+                  <a:srgbClr val="111111"/>
+                </a:solidFill>
+                <a:latin typeface="Arial"/>
+                <a:ea typeface="Arial"/>
+                <a:cs typeface="Arial"/>
+              </a:rPr>
+              <a:t>GitHub: github.com/123qwe55aa；个人网站: tobyleons.xyz。</a:t>
+            </a:r>
+          </a:p>
+        </p:txBody>
+      </p:sp>
+      <p:sp>
+        <p:nvSpPr>
+          <p:cNvPr id="31" name="">
+            <a:extLst xmlns:a="http://schemas.openxmlformats.org/drawingml/2006/main">
+              <a:ext uri="{FF2B5EF4-FFF2-40B4-BE49-F238E27FC236}">
+                <a16:creationId xmlns:a16="http://schemas.microsoft.com/office/drawing/2014/main" id="{7D5203C6-6BA1-4352-BBF6-90BC4216149B}"/>
+              </a:ext>
+            </a:extLst>
+          </p:cNvPr>
+          <p:cNvSpPr>
+            <a:spLocks xmlns:a="http://schemas.openxmlformats.org/drawingml/2006/main" noGrp="1"/>
+          </p:cNvSpPr>
+          <p:nvPr/>
+        </p:nvSpPr>
+        <p:spPr>
+          <a:xfrm xmlns:a="http://schemas.openxmlformats.org/drawingml/2006/main">
+            <a:off x="266700" y="7602601"/>
+            <a:ext cx="2667000" cy="190500"/>
+          </a:xfrm>
+          <a:prstGeom xmlns:a="http://schemas.openxmlformats.org/drawingml/2006/main" prst="rect">
+            <a:avLst/>
+          </a:prstGeom>
+          <a:noFill xmlns:a="http://schemas.openxmlformats.org/drawingml/2006/main"/>
+          <a:ln xmlns:a="http://schemas.openxmlformats.org/drawingml/2006/main" w="0">
+            <a:noFill/>
+            <a:prstDash val="solid"/>
+          </a:ln>
+        </p:spPr>
+        <p:txBody>
+          <a:bodyPr xmlns:a="http://schemas.openxmlformats.org/drawingml/2006/main" wrap="square" lIns="18300" tIns="18300" rIns="18300" bIns="18300" anchor="t"/>
+          <a:lstStyle xmlns:a="http://schemas.openxmlformats.org/drawingml/2006/main"/>
+          <a:p xmlns:a="http://schemas.openxmlformats.org/drawingml/2006/main">
+            <a:pPr algn="l">
+              <a:lnSpc>
+                <a:spcPct val="80000"/>
+              </a:lnSpc>
+              <a:buNone/>
+              <a:defRPr sz="1200" b="1">
+                <a:solidFill>
+                  <a:srgbClr val="000000"/>
+                </a:solidFill>
+                <a:latin typeface="Arial"/>
+                <a:ea typeface="Arial"/>
+                <a:cs typeface="Arial"/>
+              </a:defRPr>
+            </a:pPr>
+            <a:r>
+              <a:rPr sz="1200" b="1">
+                <a:solidFill>
+                  <a:srgbClr val="000000"/>
+                </a:solidFill>
+                <a:latin typeface="Arial"/>
+                <a:ea typeface="Arial"/>
+                <a:cs typeface="Arial"/>
+              </a:rPr>
+              <a:t>个人简介</a:t>
+            </a:r>
+          </a:p>
+        </p:txBody>
+      </p:sp>
+      <p:sp>
+        <p:nvSpPr>
+          <p:cNvPr id="32" name="">
+            <a:extLst xmlns:a="http://schemas.openxmlformats.org/drawingml/2006/main">
+              <a:ext uri="{FF2B5EF4-FFF2-40B4-BE49-F238E27FC236}">
+                <a16:creationId xmlns:a16="http://schemas.microsoft.com/office/drawing/2014/main" id="{6D34C694-F53B-4362-B9EC-B76F94170656}"/>
+              </a:ext>
+            </a:extLst>
+          </p:cNvPr>
+          <p:cNvSpPr>
+            <a:spLocks xmlns:a="http://schemas.openxmlformats.org/drawingml/2006/main" noGrp="1"/>
+          </p:cNvSpPr>
+          <p:nvPr/>
+        </p:nvSpPr>
+        <p:spPr>
+          <a:xfrm xmlns:a="http://schemas.openxmlformats.org/drawingml/2006/main">
+            <a:off x="266700" y="7798101"/>
+            <a:ext cx="7239000" cy="20955"/>
+          </a:xfrm>
+          <a:prstGeom xmlns:a="http://schemas.openxmlformats.org/drawingml/2006/main" prst="rect">
+            <a:avLst/>
+          </a:prstGeom>
+          <a:solidFill xmlns:a="http://schemas.openxmlformats.org/drawingml/2006/main">
+            <a:srgbClr val="000000"/>
+          </a:solidFill>
+          <a:ln xmlns:a="http://schemas.openxmlformats.org/drawingml/2006/main" w="0">
+            <a:solidFill>
+              <a:srgbClr val="000000"/>
+            </a:solidFill>
+            <a:prstDash val="solid"/>
+          </a:ln>
+        </p:spPr>
+      </p:sp>
+      <p:sp>
+        <p:nvSpPr>
+          <p:cNvPr id="33" name="">
+            <a:extLst xmlns:a="http://schemas.openxmlformats.org/drawingml/2006/main">
+              <a:ext uri="{FF2B5EF4-FFF2-40B4-BE49-F238E27FC236}">
+                <a16:creationId xmlns:a16="http://schemas.microsoft.com/office/drawing/2014/main" id="{E29DE8E5-0CA5-4FD3-9290-06F846F5557E}"/>
+              </a:ext>
+            </a:extLst>
+          </p:cNvPr>
+          <p:cNvSpPr>
+            <a:spLocks xmlns:a="http://schemas.openxmlformats.org/drawingml/2006/main" noGrp="1"/>
+          </p:cNvSpPr>
+          <p:nvPr/>
+        </p:nvSpPr>
+        <p:spPr>
+          <a:xfrm xmlns:a="http://schemas.openxmlformats.org/drawingml/2006/main">
+            <a:off x="266700" y="7819056"/>
+            <a:ext cx="7000875" cy="552450"/>
+          </a:xfrm>
+          <a:prstGeom xmlns:a="http://schemas.openxmlformats.org/drawingml/2006/main" prst="rect">
+            <a:avLst/>
+          </a:prstGeom>
+          <a:noFill xmlns:a="http://schemas.openxmlformats.org/drawingml/2006/main"/>
+          <a:ln xmlns:a="http://schemas.openxmlformats.org/drawingml/2006/main" w="0">
+            <a:noFill/>
+            <a:prstDash val="solid"/>
+          </a:ln>
+        </p:spPr>
+        <p:txBody>
+          <a:bodyPr xmlns:a="http://schemas.openxmlformats.org/drawingml/2006/main" wrap="square" lIns="18300" tIns="18300" rIns="18300" bIns="18300" anchor="t"/>
+          <a:lstStyle xmlns:a="http://schemas.openxmlformats.org/drawingml/2006/main"/>
+          <a:p xmlns:a="http://schemas.openxmlformats.org/drawingml/2006/main">
+            <a:pPr algn="l">
+              <a:lnSpc>
+                <a:spcPct val="80000"/>
+              </a:lnSpc>
+              <a:buNone/>
+              <a:defRPr sz="975" b="0">
+                <a:solidFill>
+                  <a:srgbClr val="111111"/>
+                </a:solidFill>
+                <a:latin typeface="Arial"/>
+                <a:ea typeface="Arial"/>
+                <a:cs typeface="Arial"/>
+              </a:defRPr>
+            </a:pPr>
+            <a:r>
+              <a:rPr sz="975" b="0">
+                <a:solidFill>
+                  <a:srgbClr val="111111"/>
+                </a:solidFill>
+                <a:latin typeface="Arial"/>
+                <a:ea typeface="Arial"/>
+                <a:cs typeface="Arial"/>
+              </a:rPr>
+              <a:t>具备客户服务、项目执行、数据分析与材料工程学习背景。能在快节奏现场与服务岗位中保持细致、稳定的执行力，重视沟通反馈与问题闭环，适合服务运营、项目协助、质量与材料相关岗位。</a:t>
             </a:r>
           </a:p>
         </p:txBody>
@@ -2908,7 +3946,7 @@
         </p:nvSpPr>
         <p:spPr>
           <a:xfrm xmlns:a="http://schemas.openxmlformats.org/drawingml/2006/main">
-            <a:off x="5810250" y="5772150"/>
+            <a:off x="5810250" y="5092446"/>
             <a:ext cx="1428750" cy="190500"/>
           </a:xfrm>
           <a:prstGeom xmlns:a="http://schemas.openxmlformats.org/drawingml/2006/main" prst="rect">
@@ -2921,12 +3959,12 @@
           </a:ln>
         </p:spPr>
         <p:txBody>
-          <a:bodyPr xmlns:a="http://schemas.openxmlformats.org/drawingml/2006/main" wrap="square" lIns="0" tIns="0" rIns="0" bIns="0" anchor="t"/>
+          <a:bodyPr xmlns:a="http://schemas.openxmlformats.org/drawingml/2006/main" wrap="square" lIns="18300" tIns="18300" rIns="18300" bIns="18300" anchor="t"/>
           <a:lstStyle xmlns:a="http://schemas.openxmlformats.org/drawingml/2006/main"/>
           <a:p xmlns:a="http://schemas.openxmlformats.org/drawingml/2006/main">
             <a:pPr algn="r">
               <a:lnSpc>
-                <a:spcPct val="108000"/>
+                <a:spcPct val="80000"/>
               </a:lnSpc>
               <a:buNone/>
               <a:defRPr sz="1058" b="1">
@@ -2952,679 +3990,122 @@
           </a:p>
         </p:txBody>
       </p:sp>
-      <p:sp>
-        <p:nvSpPr>
-          <p:cNvPr id="27" name="">
-            <a:extLst xmlns:a="http://schemas.openxmlformats.org/drawingml/2006/main">
-              <a:ext uri="{FF2B5EF4-FFF2-40B4-BE49-F238E27FC236}">
-                <a16:creationId xmlns:a16="http://schemas.microsoft.com/office/drawing/2014/main" id="{23973BF4-0F4A-47F4-A3BB-9CAF2085E38E}"/>
-              </a:ext>
-            </a:extLst>
-          </p:cNvPr>
-          <p:cNvSpPr>
-            <a:spLocks xmlns:a="http://schemas.openxmlformats.org/drawingml/2006/main" noGrp="1"/>
-          </p:cNvSpPr>
+      <p:sp xmlns:a="http://schemas.openxmlformats.org/drawingml/2006/main">
+        <p:nvSpPr>
+          <p:cNvPr id="35" name="TextBox 34"/>
+          <p:cNvSpPr txBox="1"/>
           <p:nvPr/>
         </p:nvSpPr>
         <p:spPr>
-          <a:xfrm xmlns:a="http://schemas.openxmlformats.org/drawingml/2006/main">
-            <a:off x="266700" y="6010275"/>
-            <a:ext cx="7000875" cy="476250"/>
+          <a:xfrm>
+            <a:off x="266700" y="2156460"/>
+            <a:ext cx="4953000" cy="190500"/>
           </a:xfrm>
-          <a:prstGeom xmlns:a="http://schemas.openxmlformats.org/drawingml/2006/main" prst="rect">
-            <a:avLst/>
-          </a:prstGeom>
-          <a:noFill xmlns:a="http://schemas.openxmlformats.org/drawingml/2006/main"/>
-          <a:ln xmlns:a="http://schemas.openxmlformats.org/drawingml/2006/main" w="0">
-            <a:noFill/>
-            <a:prstDash val="solid"/>
-          </a:ln>
-        </p:spPr>
-        <p:txBody>
-          <a:bodyPr xmlns:a="http://schemas.openxmlformats.org/drawingml/2006/main" wrap="square" lIns="0" tIns="0" rIns="0" bIns="0" anchor="t"/>
-          <a:lstStyle xmlns:a="http://schemas.openxmlformats.org/drawingml/2006/main"/>
-          <a:p xmlns:a="http://schemas.openxmlformats.org/drawingml/2006/main">
-            <a:pPr marL="12" indent="-10" algn="l">
+          <a:prstGeom prst="rect">
+            <a:avLst/>
+          </a:prstGeom>
+          <a:noFill/>
+        </p:spPr>
+        <p:txBody>
+          <a:bodyPr wrap="square" lIns="18300" rIns="18300" tIns="18300" bIns="18300">
+            <a:spAutoFit/>
+          </a:bodyPr>
+          <a:lstStyle/>
+          <a:p>
+            <a:r>
+              <a:rPr sz="1000" b="1">
+                <a:solidFill>
+                  <a:srgbClr val="2E75B6"/>
+                </a:solidFill>
+                <a:latin typeface="Arial"/>
+              </a:rPr>
+              <a:t>深圳能源环保股份有限公司 | 信息安全助理 | 深圳</a:t>
+            </a:r>
+            <a:pPr>
               <a:lnSpc>
-                <a:spcPct val="108000"/>
+                <a:spcPct val="80000"/>
               </a:lnSpc>
-              <a:spcAft>
-                <a:spcPts val="3"/>
-              </a:spcAft>
-              <a:buNone/>
-              <a:defRPr sz="953" b="0">
-                <a:solidFill>
-                  <a:srgbClr val="111111"/>
-                </a:solidFill>
-                <a:latin typeface="Arial"/>
-                <a:ea typeface="Arial"/>
-                <a:cs typeface="Arial"/>
-              </a:defRPr>
             </a:pPr>
-            <a:r>
-              <a:rPr sz="953">
-                <a:solidFill>
-                  <a:srgbClr val="111111"/>
-                </a:solidFill>
-                <a:latin typeface="Arial"/>
-                <a:ea typeface="Arial"/>
-                <a:cs typeface="Arial"/>
-              </a:rPr>
-              <a:t>• </a:t>
-            </a:r>
-            <a:r>
-              <a:rPr sz="953" b="1">
-                <a:solidFill>
-                  <a:srgbClr val="111111"/>
-                </a:solidFill>
-                <a:latin typeface="Arial"/>
-                <a:ea typeface="Arial"/>
-                <a:cs typeface="Arial"/>
-              </a:rPr>
-              <a:t>项目内容：</a:t>
-            </a:r>
-            <a:r>
-              <a:rPr sz="953">
-                <a:solidFill>
-                  <a:srgbClr val="111111"/>
-                </a:solidFill>
-                <a:latin typeface="Arial"/>
-                <a:ea typeface="Arial"/>
-                <a:cs typeface="Arial"/>
-              </a:rPr>
-              <a:t>围绕宿舍场景的小型零售需求，参与零食箱日常运营、库存补充与记录维护。</a:t>
-            </a:r>
           </a:p>
-          <a:p xmlns:a="http://schemas.openxmlformats.org/drawingml/2006/main">
-            <a:pPr marL="12" indent="-10" algn="l">
+        </p:txBody>
+      </p:sp>
+      <p:sp xmlns:a="http://schemas.openxmlformats.org/drawingml/2006/main">
+        <p:nvSpPr>
+          <p:cNvPr id="36" name="TextBox 35"/>
+          <p:cNvSpPr txBox="1"/>
+          <p:nvPr/>
+        </p:nvSpPr>
+        <p:spPr>
+          <a:xfrm>
+            <a:off x="5810250" y="2156460"/>
+            <a:ext cx="1587500" cy="190500"/>
+          </a:xfrm>
+          <a:prstGeom prst="rect">
+            <a:avLst/>
+          </a:prstGeom>
+          <a:noFill/>
+        </p:spPr>
+        <p:txBody>
+          <a:bodyPr wrap="square" lIns="18300" rIns="18300" tIns="18300" bIns="18300">
+            <a:spAutoFit/>
+          </a:bodyPr>
+          <a:lstStyle/>
+          <a:p>
+            <a:pPr algn="r">
               <a:lnSpc>
-                <a:spcPct val="108000"/>
+                <a:spcPct val="80000"/>
               </a:lnSpc>
-              <a:spcAft>
-                <a:spcPts val="3"/>
-              </a:spcAft>
-              <a:buNone/>
-              <a:defRPr sz="953" b="0">
-                <a:solidFill>
-                  <a:srgbClr val="111111"/>
-                </a:solidFill>
-                <a:latin typeface="Arial"/>
-                <a:ea typeface="Arial"/>
-                <a:cs typeface="Arial"/>
-              </a:defRPr>
             </a:pPr>
             <a:r>
-              <a:rPr sz="953">
-                <a:solidFill>
-                  <a:srgbClr val="111111"/>
-                </a:solidFill>
-                <a:latin typeface="Arial"/>
-                <a:ea typeface="Arial"/>
-                <a:cs typeface="Arial"/>
-              </a:rPr>
-              <a:t>• </a:t>
-            </a:r>
-            <a:r>
-              <a:rPr sz="953" b="1">
-                <a:solidFill>
-                  <a:srgbClr val="111111"/>
-                </a:solidFill>
-                <a:latin typeface="Arial"/>
-                <a:ea typeface="Arial"/>
-                <a:cs typeface="Arial"/>
-              </a:rPr>
-              <a:t>运营支持：</a:t>
-            </a:r>
-            <a:r>
-              <a:rPr sz="953">
-                <a:solidFill>
-                  <a:srgbClr val="111111"/>
-                </a:solidFill>
-                <a:latin typeface="Arial"/>
-                <a:ea typeface="Arial"/>
-                <a:cs typeface="Arial"/>
-              </a:rPr>
-              <a:t>关注商品消耗与补货节奏，配合同学反馈调整品类，提升项目运转稳定性。</a:t>
+              <a:rPr sz="1000">
+                <a:solidFill>
+                  <a:srgbClr val="111111"/>
+                </a:solidFill>
+                <a:latin typeface="Arial"/>
+              </a:rPr>
+              <a:t>2026.01 - 2026.03</a:t>
             </a:r>
           </a:p>
         </p:txBody>
       </p:sp>
-      <p:sp>
-        <p:nvSpPr>
-          <p:cNvPr id="28" name="">
-            <a:extLst xmlns:a="http://schemas.openxmlformats.org/drawingml/2006/main">
-              <a:ext uri="{FF2B5EF4-FFF2-40B4-BE49-F238E27FC236}">
-                <a16:creationId xmlns:a16="http://schemas.microsoft.com/office/drawing/2014/main" id="{F5921FB4-43DC-4E59-A504-3924B9EF9D58}"/>
-              </a:ext>
-            </a:extLst>
-          </p:cNvPr>
-          <p:cNvSpPr>
-            <a:spLocks xmlns:a="http://schemas.openxmlformats.org/drawingml/2006/main" noGrp="1"/>
-          </p:cNvSpPr>
+      <p:sp xmlns:a="http://schemas.openxmlformats.org/drawingml/2006/main">
+        <p:nvSpPr>
+          <p:cNvPr id="37" name="TextBox 36"/>
+          <p:cNvSpPr txBox="1"/>
           <p:nvPr/>
         </p:nvSpPr>
         <p:spPr>
-          <a:xfrm xmlns:a="http://schemas.openxmlformats.org/drawingml/2006/main">
-            <a:off x="266700" y="6572250"/>
-            <a:ext cx="2667000" cy="190500"/>
+          <a:xfrm>
+            <a:off x="266700" y="2346960"/>
+            <a:ext cx="7137450" cy="520065"/>
           </a:xfrm>
-          <a:prstGeom xmlns:a="http://schemas.openxmlformats.org/drawingml/2006/main" prst="rect">
-            <a:avLst/>
-          </a:prstGeom>
-          <a:noFill xmlns:a="http://schemas.openxmlformats.org/drawingml/2006/main"/>
-          <a:ln xmlns:a="http://schemas.openxmlformats.org/drawingml/2006/main" w="0">
-            <a:noFill/>
-            <a:prstDash val="solid"/>
-          </a:ln>
-        </p:spPr>
-        <p:txBody>
-          <a:bodyPr xmlns:a="http://schemas.openxmlformats.org/drawingml/2006/main" wrap="square" lIns="0" tIns="0" rIns="0" bIns="0" anchor="t"/>
-          <a:lstStyle xmlns:a="http://schemas.openxmlformats.org/drawingml/2006/main"/>
-          <a:p xmlns:a="http://schemas.openxmlformats.org/drawingml/2006/main">
-            <a:pPr algn="l">
+          <a:prstGeom prst="rect">
+            <a:avLst/>
+          </a:prstGeom>
+          <a:noFill/>
+        </p:spPr>
+        <p:txBody>
+          <a:bodyPr wrap="square" lIns="18300" rIns="18300" tIns="18300" bIns="18300">
+            <a:spAutoFit/>
+          </a:bodyPr>
+          <a:lstStyle/>
+          <a:p>
+            <a:r>
+              <a:rPr sz="900">
+                <a:solidFill>
+                  <a:srgbClr val="111111"/>
+                </a:solidFill>
+                <a:latin typeface="Arial"/>
+              </a:rPr>
+              <a:t>• SOC 安全监控：负责安全运营中心（SOC）安全事件监控值守，记录并初步跟进安全告警，协助事件响应。
+• 安全运维：参与日常网络安全维护，包括信息安全实时监控与网络安全台账管理。
+• 文档整理：整理安全事件资料，维护网络安全台账，汇总相关数据用于报告。</a:t>
+            </a:r>
+            <a:pPr>
               <a:lnSpc>
-                <a:spcPct val="108000"/>
+                <a:spcPct val="80000"/>
               </a:lnSpc>
-              <a:buNone/>
-              <a:defRPr sz="1200" b="1">
-                <a:solidFill>
-                  <a:srgbClr val="000000"/>
-                </a:solidFill>
-                <a:latin typeface="Arial"/>
-                <a:ea typeface="Arial"/>
-                <a:cs typeface="Arial"/>
-              </a:defRPr>
             </a:pPr>
-            <a:r>
-              <a:rPr sz="1200" b="1">
-                <a:solidFill>
-                  <a:srgbClr val="000000"/>
-                </a:solidFill>
-                <a:latin typeface="Arial"/>
-                <a:ea typeface="Arial"/>
-                <a:cs typeface="Arial"/>
-              </a:rPr>
-              <a:t>素质能力</a:t>
-            </a:r>
-          </a:p>
-        </p:txBody>
-      </p:sp>
-      <p:sp>
-        <p:nvSpPr>
-          <p:cNvPr id="29" name="">
-            <a:extLst xmlns:a="http://schemas.openxmlformats.org/drawingml/2006/main">
-              <a:ext uri="{FF2B5EF4-FFF2-40B4-BE49-F238E27FC236}">
-                <a16:creationId xmlns:a16="http://schemas.microsoft.com/office/drawing/2014/main" id="{C6D3A077-C816-4E7A-AF71-32BEEA63064A}"/>
-              </a:ext>
-            </a:extLst>
-          </p:cNvPr>
-          <p:cNvSpPr>
-            <a:spLocks xmlns:a="http://schemas.openxmlformats.org/drawingml/2006/main" noGrp="1"/>
-          </p:cNvSpPr>
-          <p:nvPr/>
-        </p:nvSpPr>
-        <p:spPr>
-          <a:xfrm xmlns:a="http://schemas.openxmlformats.org/drawingml/2006/main">
-            <a:off x="266700" y="6791325"/>
-            <a:ext cx="7239000" cy="20955"/>
-          </a:xfrm>
-          <a:prstGeom xmlns:a="http://schemas.openxmlformats.org/drawingml/2006/main" prst="rect">
-            <a:avLst/>
-          </a:prstGeom>
-          <a:solidFill xmlns:a="http://schemas.openxmlformats.org/drawingml/2006/main">
-            <a:srgbClr val="000000"/>
-          </a:solidFill>
-          <a:ln xmlns:a="http://schemas.openxmlformats.org/drawingml/2006/main" w="0">
-            <a:solidFill>
-              <a:srgbClr val="000000"/>
-            </a:solidFill>
-            <a:prstDash val="solid"/>
-          </a:ln>
-        </p:spPr>
-      </p:sp>
-      <p:sp>
-        <p:nvSpPr>
-          <p:cNvPr id="30" name="">
-            <a:extLst xmlns:a="http://schemas.openxmlformats.org/drawingml/2006/main">
-              <a:ext uri="{FF2B5EF4-FFF2-40B4-BE49-F238E27FC236}">
-                <a16:creationId xmlns:a16="http://schemas.microsoft.com/office/drawing/2014/main" id="{12709166-4620-4276-9D27-47C9C96D523D}"/>
-              </a:ext>
-            </a:extLst>
-          </p:cNvPr>
-          <p:cNvSpPr>
-            <a:spLocks xmlns:a="http://schemas.openxmlformats.org/drawingml/2006/main" noGrp="1"/>
-          </p:cNvSpPr>
-          <p:nvPr/>
-        </p:nvSpPr>
-        <p:spPr>
-          <a:xfrm xmlns:a="http://schemas.openxmlformats.org/drawingml/2006/main">
-            <a:off x="266700" y="6896100"/>
-            <a:ext cx="7000875" cy="1047750"/>
-          </a:xfrm>
-          <a:prstGeom xmlns:a="http://schemas.openxmlformats.org/drawingml/2006/main" prst="rect">
-            <a:avLst/>
-          </a:prstGeom>
-          <a:noFill xmlns:a="http://schemas.openxmlformats.org/drawingml/2006/main"/>
-          <a:ln xmlns:a="http://schemas.openxmlformats.org/drawingml/2006/main" w="0">
-            <a:noFill/>
-            <a:prstDash val="solid"/>
-          </a:ln>
-        </p:spPr>
-        <p:txBody>
-          <a:bodyPr xmlns:a="http://schemas.openxmlformats.org/drawingml/2006/main" wrap="square" lIns="0" tIns="0" rIns="0" bIns="0" anchor="t"/>
-          <a:lstStyle xmlns:a="http://schemas.openxmlformats.org/drawingml/2006/main"/>
-          <a:p xmlns:a="http://schemas.openxmlformats.org/drawingml/2006/main">
-            <a:pPr marL="12" indent="-10" algn="l">
-              <a:lnSpc>
-                <a:spcPct val="108000"/>
-              </a:lnSpc>
-              <a:spcAft>
-                <a:spcPts val="3"/>
-              </a:spcAft>
-              <a:buNone/>
-              <a:defRPr sz="953" b="0">
-                <a:solidFill>
-                  <a:srgbClr val="111111"/>
-                </a:solidFill>
-                <a:latin typeface="Arial"/>
-                <a:ea typeface="Arial"/>
-                <a:cs typeface="Arial"/>
-              </a:defRPr>
-            </a:pPr>
-            <a:r>
-              <a:rPr sz="953">
-                <a:solidFill>
-                  <a:srgbClr val="111111"/>
-                </a:solidFill>
-                <a:latin typeface="Arial"/>
-                <a:ea typeface="Arial"/>
-                <a:cs typeface="Arial"/>
-              </a:rPr>
-              <a:t>• </a:t>
-            </a:r>
-            <a:r>
-              <a:rPr sz="953" b="1">
-                <a:solidFill>
-                  <a:srgbClr val="111111"/>
-                </a:solidFill>
-                <a:latin typeface="Arial"/>
-                <a:ea typeface="Arial"/>
-                <a:cs typeface="Arial"/>
-              </a:rPr>
-              <a:t>语言水平：</a:t>
-            </a:r>
-            <a:r>
-              <a:rPr sz="953">
-                <a:solidFill>
-                  <a:srgbClr val="111111"/>
-                </a:solidFill>
-                <a:latin typeface="Arial"/>
-                <a:ea typeface="Arial"/>
-                <a:cs typeface="Arial"/>
-              </a:rPr>
-              <a:t>雅思 6.0；英语具备职业工作能力；普通话、粤语母语 / 双语。</a:t>
-            </a:r>
-          </a:p>
-          <a:p xmlns:a="http://schemas.openxmlformats.org/drawingml/2006/main">
-            <a:pPr marL="12" indent="-10" algn="l">
-              <a:lnSpc>
-                <a:spcPct val="108000"/>
-              </a:lnSpc>
-              <a:spcAft>
-                <a:spcPts val="3"/>
-              </a:spcAft>
-              <a:buNone/>
-              <a:defRPr sz="953" b="0">
-                <a:solidFill>
-                  <a:srgbClr val="111111"/>
-                </a:solidFill>
-                <a:latin typeface="Arial"/>
-                <a:ea typeface="Arial"/>
-                <a:cs typeface="Arial"/>
-              </a:defRPr>
-            </a:pPr>
-            <a:r>
-              <a:rPr sz="953">
-                <a:solidFill>
-                  <a:srgbClr val="111111"/>
-                </a:solidFill>
-                <a:latin typeface="Arial"/>
-                <a:ea typeface="Arial"/>
-                <a:cs typeface="Arial"/>
-              </a:rPr>
-              <a:t>• </a:t>
-            </a:r>
-            <a:r>
-              <a:rPr sz="953" b="1">
-                <a:solidFill>
-                  <a:srgbClr val="111111"/>
-                </a:solidFill>
-                <a:latin typeface="Arial"/>
-                <a:ea typeface="Arial"/>
-                <a:cs typeface="Arial"/>
-              </a:rPr>
-              <a:t>专业技能：</a:t>
-            </a:r>
-            <a:r>
-              <a:rPr sz="953">
-                <a:solidFill>
-                  <a:srgbClr val="111111"/>
-                </a:solidFill>
-                <a:latin typeface="Arial"/>
-                <a:ea typeface="Arial"/>
-                <a:cs typeface="Arial"/>
-              </a:rPr>
-              <a:t>具备材料检测基础、质量意识、技术文档写作、项目协调与执行能力。</a:t>
-            </a:r>
-          </a:p>
-          <a:p xmlns:a="http://schemas.openxmlformats.org/drawingml/2006/main">
-            <a:pPr marL="12" indent="-10" algn="l">
-              <a:lnSpc>
-                <a:spcPct val="108000"/>
-              </a:lnSpc>
-              <a:spcAft>
-                <a:spcPts val="3"/>
-              </a:spcAft>
-              <a:buNone/>
-              <a:defRPr sz="953" b="0">
-                <a:solidFill>
-                  <a:srgbClr val="111111"/>
-                </a:solidFill>
-                <a:latin typeface="Arial"/>
-                <a:ea typeface="Arial"/>
-                <a:cs typeface="Arial"/>
-              </a:defRPr>
-            </a:pPr>
-            <a:r>
-              <a:rPr sz="953">
-                <a:solidFill>
-                  <a:srgbClr val="111111"/>
-                </a:solidFill>
-                <a:latin typeface="Arial"/>
-                <a:ea typeface="Arial"/>
-                <a:cs typeface="Arial"/>
-              </a:rPr>
-              <a:t>• </a:t>
-            </a:r>
-            <a:r>
-              <a:rPr sz="953" b="1">
-                <a:solidFill>
-                  <a:srgbClr val="111111"/>
-                </a:solidFill>
-                <a:latin typeface="Arial"/>
-                <a:ea typeface="Arial"/>
-                <a:cs typeface="Arial"/>
-              </a:rPr>
-              <a:t>数据能力：</a:t>
-            </a:r>
-            <a:r>
-              <a:rPr sz="953">
-                <a:solidFill>
-                  <a:srgbClr val="111111"/>
-                </a:solidFill>
-                <a:latin typeface="Arial"/>
-                <a:ea typeface="Arial"/>
-                <a:cs typeface="Arial"/>
-              </a:rPr>
-              <a:t>具备数据分析与信息整理意识，能够使用数字化工具提升工作效率。</a:t>
-            </a:r>
-          </a:p>
-          <a:p xmlns:a="http://schemas.openxmlformats.org/drawingml/2006/main">
-            <a:pPr marL="12" indent="-10" algn="l">
-              <a:lnSpc>
-                <a:spcPct val="108000"/>
-              </a:lnSpc>
-              <a:spcAft>
-                <a:spcPts val="3"/>
-              </a:spcAft>
-              <a:buNone/>
-              <a:defRPr sz="953" b="0">
-                <a:solidFill>
-                  <a:srgbClr val="111111"/>
-                </a:solidFill>
-                <a:latin typeface="Arial"/>
-                <a:ea typeface="Arial"/>
-                <a:cs typeface="Arial"/>
-              </a:defRPr>
-            </a:pPr>
-            <a:r>
-              <a:rPr sz="953">
-                <a:solidFill>
-                  <a:srgbClr val="111111"/>
-                </a:solidFill>
-                <a:latin typeface="Arial"/>
-                <a:ea typeface="Arial"/>
-                <a:cs typeface="Arial"/>
-              </a:rPr>
-              <a:t>• </a:t>
-            </a:r>
-            <a:r>
-              <a:rPr sz="953" b="1">
-                <a:solidFill>
-                  <a:srgbClr val="111111"/>
-                </a:solidFill>
-                <a:latin typeface="Arial"/>
-                <a:ea typeface="Arial"/>
-                <a:cs typeface="Arial"/>
-              </a:rPr>
-              <a:t>证书许可：</a:t>
-            </a:r>
-            <a:r>
-              <a:rPr sz="953">
-                <a:solidFill>
-                  <a:srgbClr val="111111"/>
-                </a:solidFill>
-                <a:latin typeface="Arial"/>
-                <a:ea typeface="Arial"/>
-                <a:cs typeface="Arial"/>
-              </a:rPr>
-              <a:t>驾驶证；雅思 6.0。</a:t>
-            </a:r>
-          </a:p>
-          <a:p xmlns:a="http://schemas.openxmlformats.org/drawingml/2006/main">
-            <a:pPr marL="12" indent="-10" algn="l">
-              <a:lnSpc>
-                <a:spcPct val="108000"/>
-              </a:lnSpc>
-              <a:spcAft>
-                <a:spcPts val="3"/>
-              </a:spcAft>
-              <a:buNone/>
-              <a:defRPr sz="953" b="0">
-                <a:solidFill>
-                  <a:srgbClr val="111111"/>
-                </a:solidFill>
-                <a:latin typeface="Arial"/>
-                <a:ea typeface="Arial"/>
-                <a:cs typeface="Arial"/>
-              </a:defRPr>
-            </a:pPr>
-            <a:r>
-              <a:rPr sz="953">
-                <a:solidFill>
-                  <a:srgbClr val="111111"/>
-                </a:solidFill>
-                <a:latin typeface="Arial"/>
-                <a:ea typeface="Arial"/>
-                <a:cs typeface="Arial"/>
-              </a:rPr>
-              <a:t>• </a:t>
-            </a:r>
-            <a:r>
-              <a:rPr sz="953" b="1">
-                <a:solidFill>
-                  <a:srgbClr val="111111"/>
-                </a:solidFill>
-                <a:latin typeface="Arial"/>
-                <a:ea typeface="Arial"/>
-                <a:cs typeface="Arial"/>
-              </a:rPr>
-              <a:t>个人链接：</a:t>
-            </a:r>
-            <a:r>
-              <a:rPr sz="953">
-                <a:solidFill>
-                  <a:srgbClr val="111111"/>
-                </a:solidFill>
-                <a:latin typeface="Arial"/>
-                <a:ea typeface="Arial"/>
-                <a:cs typeface="Arial"/>
-              </a:rPr>
-              <a:t>GitHub: github.com/123qwe55aa；个人网站: tobyleons.xyz。</a:t>
-            </a:r>
-          </a:p>
-        </p:txBody>
-      </p:sp>
-      <p:sp>
-        <p:nvSpPr>
-          <p:cNvPr id="31" name="">
-            <a:extLst xmlns:a="http://schemas.openxmlformats.org/drawingml/2006/main">
-              <a:ext uri="{FF2B5EF4-FFF2-40B4-BE49-F238E27FC236}">
-                <a16:creationId xmlns:a16="http://schemas.microsoft.com/office/drawing/2014/main" id="{7D5203C6-6BA1-4352-BBF6-90BC4216149B}"/>
-              </a:ext>
-            </a:extLst>
-          </p:cNvPr>
-          <p:cNvSpPr>
-            <a:spLocks xmlns:a="http://schemas.openxmlformats.org/drawingml/2006/main" noGrp="1"/>
-          </p:cNvSpPr>
-          <p:nvPr/>
-        </p:nvSpPr>
-        <p:spPr>
-          <a:xfrm xmlns:a="http://schemas.openxmlformats.org/drawingml/2006/main">
-            <a:off x="266700" y="8048625"/>
-            <a:ext cx="2667000" cy="190500"/>
-          </a:xfrm>
-          <a:prstGeom xmlns:a="http://schemas.openxmlformats.org/drawingml/2006/main" prst="rect">
-            <a:avLst/>
-          </a:prstGeom>
-          <a:noFill xmlns:a="http://schemas.openxmlformats.org/drawingml/2006/main"/>
-          <a:ln xmlns:a="http://schemas.openxmlformats.org/drawingml/2006/main" w="0">
-            <a:noFill/>
-            <a:prstDash val="solid"/>
-          </a:ln>
-        </p:spPr>
-        <p:txBody>
-          <a:bodyPr xmlns:a="http://schemas.openxmlformats.org/drawingml/2006/main" wrap="square" lIns="0" tIns="0" rIns="0" bIns="0" anchor="t"/>
-          <a:lstStyle xmlns:a="http://schemas.openxmlformats.org/drawingml/2006/main"/>
-          <a:p xmlns:a="http://schemas.openxmlformats.org/drawingml/2006/main">
-            <a:pPr algn="l">
-              <a:lnSpc>
-                <a:spcPct val="108000"/>
-              </a:lnSpc>
-              <a:buNone/>
-              <a:defRPr sz="1200" b="1">
-                <a:solidFill>
-                  <a:srgbClr val="000000"/>
-                </a:solidFill>
-                <a:latin typeface="Arial"/>
-                <a:ea typeface="Arial"/>
-                <a:cs typeface="Arial"/>
-              </a:defRPr>
-            </a:pPr>
-            <a:r>
-              <a:rPr sz="1200" b="1">
-                <a:solidFill>
-                  <a:srgbClr val="000000"/>
-                </a:solidFill>
-                <a:latin typeface="Arial"/>
-                <a:ea typeface="Arial"/>
-                <a:cs typeface="Arial"/>
-              </a:rPr>
-              <a:t>个人简介</a:t>
-            </a:r>
-          </a:p>
-        </p:txBody>
-      </p:sp>
-      <p:sp>
-        <p:nvSpPr>
-          <p:cNvPr id="32" name="">
-            <a:extLst xmlns:a="http://schemas.openxmlformats.org/drawingml/2006/main">
-              <a:ext uri="{FF2B5EF4-FFF2-40B4-BE49-F238E27FC236}">
-                <a16:creationId xmlns:a16="http://schemas.microsoft.com/office/drawing/2014/main" id="{6D34C694-F53B-4362-B9EC-B76F94170656}"/>
-              </a:ext>
-            </a:extLst>
-          </p:cNvPr>
-          <p:cNvSpPr>
-            <a:spLocks xmlns:a="http://schemas.openxmlformats.org/drawingml/2006/main" noGrp="1"/>
-          </p:cNvSpPr>
-          <p:nvPr/>
-        </p:nvSpPr>
-        <p:spPr>
-          <a:xfrm xmlns:a="http://schemas.openxmlformats.org/drawingml/2006/main">
-            <a:off x="266700" y="8267700"/>
-            <a:ext cx="7239000" cy="20955"/>
-          </a:xfrm>
-          <a:prstGeom xmlns:a="http://schemas.openxmlformats.org/drawingml/2006/main" prst="rect">
-            <a:avLst/>
-          </a:prstGeom>
-          <a:solidFill xmlns:a="http://schemas.openxmlformats.org/drawingml/2006/main">
-            <a:srgbClr val="000000"/>
-          </a:solidFill>
-          <a:ln xmlns:a="http://schemas.openxmlformats.org/drawingml/2006/main" w="0">
-            <a:solidFill>
-              <a:srgbClr val="000000"/>
-            </a:solidFill>
-            <a:prstDash val="solid"/>
-          </a:ln>
-        </p:spPr>
-      </p:sp>
-      <p:sp>
-        <p:nvSpPr>
-          <p:cNvPr id="33" name="">
-            <a:extLst xmlns:a="http://schemas.openxmlformats.org/drawingml/2006/main">
-              <a:ext uri="{FF2B5EF4-FFF2-40B4-BE49-F238E27FC236}">
-                <a16:creationId xmlns:a16="http://schemas.microsoft.com/office/drawing/2014/main" id="{E29DE8E5-0CA5-4FD3-9290-06F846F5557E}"/>
-              </a:ext>
-            </a:extLst>
-          </p:cNvPr>
-          <p:cNvSpPr>
-            <a:spLocks xmlns:a="http://schemas.openxmlformats.org/drawingml/2006/main" noGrp="1"/>
-          </p:cNvSpPr>
-          <p:nvPr/>
-        </p:nvSpPr>
-        <p:spPr>
-          <a:xfrm xmlns:a="http://schemas.openxmlformats.org/drawingml/2006/main">
-            <a:off x="266700" y="8362950"/>
-            <a:ext cx="7000875" cy="552450"/>
-          </a:xfrm>
-          <a:prstGeom xmlns:a="http://schemas.openxmlformats.org/drawingml/2006/main" prst="rect">
-            <a:avLst/>
-          </a:prstGeom>
-          <a:noFill xmlns:a="http://schemas.openxmlformats.org/drawingml/2006/main"/>
-          <a:ln xmlns:a="http://schemas.openxmlformats.org/drawingml/2006/main" w="0">
-            <a:noFill/>
-            <a:prstDash val="solid"/>
-          </a:ln>
-        </p:spPr>
-        <p:txBody>
-          <a:bodyPr xmlns:a="http://schemas.openxmlformats.org/drawingml/2006/main" wrap="square" lIns="0" tIns="0" rIns="0" bIns="0" anchor="t"/>
-          <a:lstStyle xmlns:a="http://schemas.openxmlformats.org/drawingml/2006/main"/>
-          <a:p xmlns:a="http://schemas.openxmlformats.org/drawingml/2006/main">
-            <a:pPr algn="l">
-              <a:lnSpc>
-                <a:spcPct val="122000"/>
-              </a:lnSpc>
-              <a:buNone/>
-              <a:defRPr sz="975" b="0">
-                <a:solidFill>
-                  <a:srgbClr val="111111"/>
-                </a:solidFill>
-                <a:latin typeface="Arial"/>
-                <a:ea typeface="Arial"/>
-                <a:cs typeface="Arial"/>
-              </a:defRPr>
-            </a:pPr>
-            <a:r>
-              <a:rPr sz="975" b="0">
-                <a:solidFill>
-                  <a:srgbClr val="111111"/>
-                </a:solidFill>
-                <a:latin typeface="Arial"/>
-                <a:ea typeface="Arial"/>
-                <a:cs typeface="Arial"/>
-              </a:rPr>
-              <a:t>具备客户服务、项目执行、数据分析与材料工程学习背景。能在快节奏现场与服务岗位中保持细致、稳定的执行力，重视沟通反馈与问题闭环，适合服务运营、项目协助、质量与材料相关岗位。</a:t>
-            </a:r>
           </a:p>
         </p:txBody>
       </p:sp>
@@ -3635,390 +4116,6 @@
       </p:ext>
     </p:extLst>
   </p:cSld>
-</p:sld>
-</file>
-
-<file path=ppt/slides/slide2.xml><?xml version="1.0" encoding="utf-8"?>
-<p:sld xmlns:a="http://schemas.openxmlformats.org/drawingml/2006/main" xmlns:p="http://schemas.openxmlformats.org/presentationml/2006/main" xmlns:r="http://schemas.openxmlformats.org/officeDocument/2006/relationships">
-  <p:cSld>
-    <p:spTree>
-      <p:nvGrpSpPr>
-        <p:cNvPr id="1" name=""/>
-        <p:cNvGrpSpPr/>
-        <p:nvPr/>
-      </p:nvGrpSpPr>
-      <p:grpSpPr/>
-      <p:sp>
-        <p:nvSpPr>
-          <p:cNvPr id="2" name="TextBox 1"/>
-          <p:cNvSpPr txBox="1"/>
-          <p:nvPr/>
-        </p:nvSpPr>
-        <p:spPr>
-          <a:xfrm>
-            <a:off x="457200" y="274320"/>
-            <a:ext cx="8229600" cy="731520"/>
-          </a:xfrm>
-          <a:prstGeom prst="rect">
-            <a:avLst/>
-          </a:prstGeom>
-          <a:noFill/>
-        </p:spPr>
-        <p:txBody>
-          <a:bodyPr wrap="none">
-            <a:spAutoFit/>
-          </a:bodyPr>
-          <a:lstStyle/>
-          <a:p>
-            <a:pPr>
-              <a:defRPr sz="2800" b="1"/>
-            </a:pPr>
-            <a:r>
-              <a:t>Projects Community / Vibe Coding 项目经历</a:t>
-            </a:r>
-          </a:p>
-        </p:txBody>
-      </p:sp>
-      <p:sp>
-        <p:nvSpPr>
-          <p:cNvPr id="3" name="TextBox 2"/>
-          <p:cNvSpPr txBox="1"/>
-          <p:nvPr/>
-        </p:nvSpPr>
-        <p:spPr>
-          <a:xfrm>
-            <a:off x="457200" y="1097280"/>
-            <a:ext cx="8229600" cy="457200"/>
-          </a:xfrm>
-          <a:prstGeom prst="rect">
-            <a:avLst/>
-          </a:prstGeom>
-          <a:noFill/>
-        </p:spPr>
-        <p:txBody>
-          <a:bodyPr wrap="none">
-            <a:spAutoFit/>
-          </a:bodyPr>
-          <a:lstStyle/>
-          <a:p>
-            <a:pPr>
-              <a:defRPr sz="1400" b="1"/>
-            </a:pPr>
-            <a:r>
-              <a:t>1. Projects Community — 全栈 AI 工作流与社区平台</a:t>
-            </a:r>
-          </a:p>
-        </p:txBody>
-      </p:sp>
-      <p:sp>
-        <p:nvSpPr>
-          <p:cNvPr id="4" name="TextBox 3"/>
-          <p:cNvSpPr txBox="1"/>
-          <p:nvPr/>
-        </p:nvSpPr>
-        <p:spPr>
-          <a:xfrm>
-            <a:off x="640080" y="1463040"/>
-            <a:ext cx="7863840" cy="1005840"/>
-          </a:xfrm>
-          <a:prstGeom prst="rect">
-            <a:avLst/>
-          </a:prstGeom>
-          <a:noFill/>
-        </p:spPr>
-        <p:txBody>
-          <a:bodyPr wrap="none">
-            <a:spAutoFit/>
-          </a:bodyPr>
-          <a:lstStyle/>
-          <a:p>
-            <a:pPr>
-              <a:lnSpc>
-                <a:spcPct val="120000"/>
-              </a:lnSpc>
-              <a:defRPr sz="1100"/>
-            </a:pPr>
-            <a:r>
-              <a:t>2024.10 – 至今</a:t>
-            </a:r>
-          </a:p>
-          <a:p>
-            <a:r>
-              <a:t>• 基于 Hermes Agent 框架部署个人 AI 助手系统，整合 Codex、Claude Code、Opencode.ai 多模型路由</a:t>
-            </a:r>
-          </a:p>
-          <a:p>
-            <a:r>
-              <a:t>• 搭建 Telegram、Discord、iMessage、API Server 多平台消息网关，SQLite 会话持久化</a:t>
-            </a:r>
-          </a:p>
-          <a:p>
-            <a:r>
-              <a:t>• Antigravity + Codex 并行代码生成与 PR Review 自动化，故障排查效率提升 60%</a:t>
-            </a:r>
-          </a:p>
-          <a:p>
-            <a:r>
-              <a:t>• 技术栈：Python 3.11、FastAPI、SQLite、systemd、Docker Compose</a:t>
-            </a:r>
-          </a:p>
-        </p:txBody>
-      </p:sp>
-      <p:sp>
-        <p:nvSpPr>
-          <p:cNvPr id="5" name="TextBox 4"/>
-          <p:cNvSpPr txBox="1"/>
-          <p:nvPr/>
-        </p:nvSpPr>
-        <p:spPr>
-          <a:xfrm>
-            <a:off x="457200" y="2560320"/>
-            <a:ext cx="8229600" cy="457200"/>
-          </a:xfrm>
-          <a:prstGeom prst="rect">
-            <a:avLst/>
-          </a:prstGeom>
-          <a:noFill/>
-        </p:spPr>
-        <p:txBody>
-          <a:bodyPr wrap="none">
-            <a:spAutoFit/>
-          </a:bodyPr>
-          <a:lstStyle/>
-          <a:p>
-            <a:pPr>
-              <a:defRPr sz="1400" b="1"/>
-            </a:pPr>
-            <a:r>
-              <a:t>2. Hermes MCP Adapter — 本地 AI 运行时外部调用适配器</a:t>
-            </a:r>
-          </a:p>
-        </p:txBody>
-      </p:sp>
-      <p:sp>
-        <p:nvSpPr>
-          <p:cNvPr id="6" name="TextBox 5"/>
-          <p:cNvSpPr txBox="1"/>
-          <p:nvPr/>
-        </p:nvSpPr>
-        <p:spPr>
-          <a:xfrm>
-            <a:off x="640080" y="2926079"/>
-            <a:ext cx="7863840" cy="1005840"/>
-          </a:xfrm>
-          <a:prstGeom prst="rect">
-            <a:avLst/>
-          </a:prstGeom>
-          <a:noFill/>
-        </p:spPr>
-        <p:txBody>
-          <a:bodyPr wrap="none">
-            <a:spAutoFit/>
-          </a:bodyPr>
-          <a:lstStyle/>
-          <a:p>
-            <a:pPr>
-              <a:lnSpc>
-                <a:spcPct val="120000"/>
-              </a:lnSpc>
-              <a:defRPr sz="1100"/>
-            </a:pPr>
-            <a:r>
-              <a:t>2025.02 – 2025.05</a:t>
-            </a:r>
-          </a:p>
-          <a:p>
-            <a:r>
-              <a:t>• 独立开发适配器，将本地 Hermes 运行时暴露为符合 MCP（Model Context Protocol）标准的服务端点</a:t>
-            </a:r>
-          </a:p>
-          <a:p>
-            <a:r>
-              <a:t>• 支持 Cursor、Claude Desktop 等客户端直接调用本地命令，实现白名单校验、HTTP 转发、健康检查</a:t>
-            </a:r>
-          </a:p>
-          <a:p>
-            <a:r>
-              <a:t>• 技术栈：TypeScript、Node.js、FastAPI、MCP stdio/HTTP</a:t>
-            </a:r>
-          </a:p>
-        </p:txBody>
-      </p:sp>
-      <p:sp>
-        <p:nvSpPr>
-          <p:cNvPr id="7" name="TextBox 6"/>
-          <p:cNvSpPr txBox="1"/>
-          <p:nvPr/>
-        </p:nvSpPr>
-        <p:spPr>
-          <a:xfrm>
-            <a:off x="457200" y="4023360"/>
-            <a:ext cx="8229600" cy="457200"/>
-          </a:xfrm>
-          <a:prstGeom prst="rect">
-            <a:avLst/>
-          </a:prstGeom>
-          <a:noFill/>
-        </p:spPr>
-        <p:txBody>
-          <a:bodyPr wrap="none">
-            <a:spAutoFit/>
-          </a:bodyPr>
-          <a:lstStyle/>
-          <a:p>
-            <a:pPr>
-              <a:defRPr sz="1400" b="1"/>
-            </a:pPr>
-            <a:r>
-              <a:t>3. AI 视频生成运镜脚本与内容运营</a:t>
-            </a:r>
-          </a:p>
-        </p:txBody>
-      </p:sp>
-      <p:sp>
-        <p:nvSpPr>
-          <p:cNvPr id="8" name="TextBox 7"/>
-          <p:cNvSpPr txBox="1"/>
-          <p:nvPr/>
-        </p:nvSpPr>
-        <p:spPr>
-          <a:xfrm>
-            <a:off x="640080" y="4389120"/>
-            <a:ext cx="7863840" cy="1005840"/>
-          </a:xfrm>
-          <a:prstGeom prst="rect">
-            <a:avLst/>
-          </a:prstGeom>
-          <a:noFill/>
-        </p:spPr>
-        <p:txBody>
-          <a:bodyPr wrap="none">
-            <a:spAutoFit/>
-          </a:bodyPr>
-          <a:lstStyle/>
-          <a:p>
-            <a:pPr>
-              <a:lnSpc>
-                <a:spcPct val="120000"/>
-              </a:lnSpc>
-              <a:defRPr sz="1100"/>
-            </a:pPr>
-            <a:r>
-              <a:t>2025.06 – 2025.07</a:t>
-            </a:r>
-          </a:p>
-          <a:p>
-            <a:r>
-              <a:t>• 主导设计“POV 梦幻油画铁轨梦境”运镜脚本：花海云端 → 海底世界 7 个场景转场</a:t>
-            </a:r>
-          </a:p>
-          <a:p>
-            <a:r>
-              <a:t>• 利用 Kling AI 3.0、Runway Gen-3、Pika 2.0 工具实现流水线化生成，单片 8-10 秒</a:t>
-            </a:r>
-          </a:p>
-          <a:p>
-            <a:r>
-              <a:t>• 建立 prompt engineering 知识库（GitHub repo），系统归纳运镜、锁定句、分段拼接策略</a:t>
-            </a:r>
-          </a:p>
-          <a:p>
-            <a:r>
-              <a:t>• 技术栈：AI Video Gen、Prompt Engineering、Markdown</a:t>
-            </a:r>
-          </a:p>
-        </p:txBody>
-      </p:sp>
-      <p:sp>
-        <p:nvSpPr>
-          <p:cNvPr id="9" name="TextBox 8"/>
-          <p:cNvSpPr txBox="1"/>
-          <p:nvPr/>
-        </p:nvSpPr>
-        <p:spPr>
-          <a:xfrm>
-            <a:off x="457200" y="5486400"/>
-            <a:ext cx="8229600" cy="457200"/>
-          </a:xfrm>
-          <a:prstGeom prst="rect">
-            <a:avLst/>
-          </a:prstGeom>
-          <a:noFill/>
-        </p:spPr>
-        <p:txBody>
-          <a:bodyPr wrap="none">
-            <a:spAutoFit/>
-          </a:bodyPr>
-          <a:lstStyle/>
-          <a:p>
-            <a:pPr>
-              <a:defRPr sz="1400" b="1"/>
-            </a:pPr>
-            <a:r>
-              <a:t>4. 混合云 VPS 基础设施与边缘计算</a:t>
-            </a:r>
-          </a:p>
-        </p:txBody>
-      </p:sp>
-      <p:sp>
-        <p:nvSpPr>
-          <p:cNvPr id="10" name="TextBox 9"/>
-          <p:cNvSpPr txBox="1"/>
-          <p:nvPr/>
-        </p:nvSpPr>
-        <p:spPr>
-          <a:xfrm>
-            <a:off x="640080" y="5852160"/>
-            <a:ext cx="7863840" cy="1005840"/>
-          </a:xfrm>
-          <a:prstGeom prst="rect">
-            <a:avLst/>
-          </a:prstGeom>
-          <a:noFill/>
-        </p:spPr>
-        <p:txBody>
-          <a:bodyPr wrap="none">
-            <a:spAutoFit/>
-          </a:bodyPr>
-          <a:lstStyle/>
-          <a:p>
-            <a:pPr>
-              <a:lnSpc>
-                <a:spcPct val="120000"/>
-              </a:lnSpc>
-              <a:defRPr sz="1100"/>
-            </a:pPr>
-            <a:r>
-              <a:t>2024.08 – 至今</a:t>
-            </a:r>
-          </a:p>
-          <a:p>
-            <a:r>
-              <a:t>• 统管腾讯云、Vultr 三台 VPS，构建 Coolify PaaS 私服 + 3x-ui 代理网关 + Cloudflare Tunnel 动态路由</a:t>
-            </a:r>
-          </a:p>
-          <a:p>
-            <a:r>
-              <a:t>• 自研 Cloudflare Tunnel 自动化配置脚本，解决 ICP 防火墙阻断问题</a:t>
-            </a:r>
-          </a:p>
-          <a:p>
-            <a:r>
-              <a:t>• 原生 systemd 部署优先策略：Hermes、PostgreSQL、Redis 原生运行，内存占用降低 40%</a:t>
-            </a:r>
-          </a:p>
-          <a:p>
-            <a:r>
-              <a:t>• 技术栈：Ubuntu 22.04、Docker、systemd、Traefik、Nginx、PostgreSQL、Redis</a:t>
-            </a:r>
-          </a:p>
-        </p:txBody>
-      </p:sp>
-    </p:spTree>
-  </p:cSld>
-  <p:clrMapOvr>
-    <a:masterClrMapping/>
-  </p:clrMapOvr>
 </p:sld>
 </file>
 

</xml_diff>